<commit_message>
fix(docs): format and structure PowerPoint presentation geometry and typography
</commit_message>
<xml_diff>
--- a/docs/gccx-candidate-triage-presentation.pptx
+++ b/docs/gccx-candidate-triage-presentation.pptx
@@ -894,7 +894,7 @@
           </a:p>
           <a:p>
             <a:r>
-              <a:t>When a recruiter clicks 'Shortlist' or 'Reject', the state persists immediately to SQLite via PATCH /api/candidates/:id/status. As seen in the bottom screenshot, a green toast notification confirms 'Candidate Kavya Kaur successfully updated to shortlisted', and the Shortlisted KPI counter increments to 1 without requiring a full page refresh.</a:t>
+              <a:t>When a recruiter clicks 'Shortlist' or 'Reject', the state persists immediately to SQLite via PATCH /api/candidates/:id/status. As seen in the bottom screenshot, a green toast confirms 'Candidate Kavya Kaur successfully updated to shortlisted', and the Shortlisted KPI counter increments to 1 without requiring a full page refresh.</a:t>
             </a:r>
           </a:p>
         </p:txBody>
@@ -4111,8 +4111,8 @@
         </p:nvSpPr>
         <p:spPr>
           <a:xfrm>
-            <a:off x="731520" y="1097280"/>
-            <a:ext cx="4114800" cy="347472"/>
+            <a:off x="731520" y="1005840"/>
+            <a:ext cx="4389120" cy="347472"/>
           </a:xfrm>
           <a:prstGeom prst="roundRect">
             <a:avLst/>
@@ -4149,6 +4149,7 @@
                 <a:solidFill>
                   <a:srgbClr val="38BDF8"/>
                 </a:solidFill>
+                <a:latin typeface="Segoe UI"/>
               </a:defRPr>
             </a:pPr>
             <a:r>
@@ -4165,8 +4166,8 @@
         </p:nvSpPr>
         <p:spPr>
           <a:xfrm>
-            <a:off x="731520" y="1645920"/>
-            <a:ext cx="10698480" cy="1097280"/>
+            <a:off x="731520" y="1536192"/>
+            <a:ext cx="10698480" cy="1005840"/>
           </a:xfrm>
           <a:prstGeom prst="rect">
             <a:avLst/>
@@ -4184,6 +4185,7 @@
                 <a:solidFill>
                   <a:srgbClr val="F8FAFC"/>
                 </a:solidFill>
+                <a:latin typeface="Segoe UI"/>
               </a:defRPr>
             </a:pPr>
             <a:r>
@@ -4200,8 +4202,8 @@
         </p:nvSpPr>
         <p:spPr>
           <a:xfrm>
-            <a:off x="731520" y="2743200"/>
-            <a:ext cx="10698480" cy="548640"/>
+            <a:off x="731520" y="2578608"/>
+            <a:ext cx="10698480" cy="502920"/>
           </a:xfrm>
           <a:prstGeom prst="rect">
             <a:avLst/>
@@ -4215,10 +4217,11 @@
           <a:lstStyle/>
           <a:p>
             <a:pPr>
-              <a:defRPr sz="1600">
+              <a:defRPr sz="1500">
                 <a:solidFill>
                   <a:srgbClr val="94A3B8"/>
                 </a:solidFill>
+                <a:latin typeface="Segoe UI"/>
               </a:defRPr>
             </a:pPr>
             <a:r>
@@ -4235,8 +4238,8 @@
         </p:nvSpPr>
         <p:spPr>
           <a:xfrm>
-            <a:off x="731520" y="3840480"/>
-            <a:ext cx="2514600" cy="2011680"/>
+            <a:off x="731520" y="3520440"/>
+            <a:ext cx="2514600" cy="2194560"/>
           </a:xfrm>
           <a:prstGeom prst="roundRect">
             <a:avLst/>
@@ -4265,17 +4268,18 @@
           </a:fontRef>
         </p:style>
         <p:txBody>
-          <a:bodyPr rtlCol="0" anchor="ctr" wrap="square" lIns="228600" rIns="228600" tIns="182880" bIns="182880"/>
+          <a:bodyPr rtlCol="0" anchor="ctr" wrap="square" lIns="219456" rIns="219456" tIns="182880" bIns="182880"/>
           <a:lstStyle/>
           <a:p>
             <a:pPr algn="ctr">
               <a:spcAft>
                 <a:spcPts val="800"/>
               </a:spcAft>
-              <a:defRPr sz="1400" b="1">
+              <a:defRPr sz="1350" b="1">
                 <a:solidFill>
                   <a:srgbClr val="38BDF8"/>
                 </a:solidFill>
+                <a:latin typeface="Segoe UI"/>
               </a:defRPr>
             </a:pPr>
             <a:r>
@@ -4288,6 +4292,7 @@
                 <a:solidFill>
                   <a:srgbClr val="94A3B8"/>
                 </a:solidFill>
+                <a:latin typeface="Segoe UI"/>
               </a:defRPr>
             </a:pPr>
             <a:r>
@@ -4304,8 +4309,8 @@
         </p:nvSpPr>
         <p:spPr>
           <a:xfrm>
-            <a:off x="3465576" y="3840480"/>
-            <a:ext cx="2514600" cy="2011680"/>
+            <a:off x="3465576" y="3520440"/>
+            <a:ext cx="2514600" cy="2194560"/>
           </a:xfrm>
           <a:prstGeom prst="roundRect">
             <a:avLst/>
@@ -4334,17 +4339,18 @@
           </a:fontRef>
         </p:style>
         <p:txBody>
-          <a:bodyPr rtlCol="0" anchor="ctr" wrap="square" lIns="228600" rIns="228600" tIns="182880" bIns="182880"/>
+          <a:bodyPr rtlCol="0" anchor="ctr" wrap="square" lIns="219456" rIns="219456" tIns="182880" bIns="182880"/>
           <a:lstStyle/>
           <a:p>
             <a:pPr algn="ctr">
               <a:spcAft>
                 <a:spcPts val="800"/>
               </a:spcAft>
-              <a:defRPr sz="1400" b="1">
+              <a:defRPr sz="1350" b="1">
                 <a:solidFill>
                   <a:srgbClr val="818CF8"/>
                 </a:solidFill>
+                <a:latin typeface="Segoe UI"/>
               </a:defRPr>
             </a:pPr>
             <a:r>
@@ -4357,10 +4363,11 @@
                 <a:solidFill>
                   <a:srgbClr val="94A3B8"/>
                 </a:solidFill>
+                <a:latin typeface="Segoe UI"/>
               </a:defRPr>
             </a:pPr>
             <a:r>
-              <a:t>SQLite WAL mode, cascade deletions, non-destructive re-seeding</a:t>
+              <a:t>SQLite WAL mode, foreign keys, cascade delete, idempotent re-seeding</a:t>
             </a:r>
           </a:p>
         </p:txBody>
@@ -4373,8 +4380,8 @@
         </p:nvSpPr>
         <p:spPr>
           <a:xfrm>
-            <a:off x="6199632" y="3840480"/>
-            <a:ext cx="2514600" cy="2011680"/>
+            <a:off x="6199632" y="3520440"/>
+            <a:ext cx="2514600" cy="2194560"/>
           </a:xfrm>
           <a:prstGeom prst="roundRect">
             <a:avLst/>
@@ -4403,17 +4410,18 @@
           </a:fontRef>
         </p:style>
         <p:txBody>
-          <a:bodyPr rtlCol="0" anchor="ctr" wrap="square" lIns="228600" rIns="228600" tIns="182880" bIns="182880"/>
+          <a:bodyPr rtlCol="0" anchor="ctr" wrap="square" lIns="219456" rIns="219456" tIns="182880" bIns="182880"/>
           <a:lstStyle/>
           <a:p>
             <a:pPr algn="ctr">
               <a:spcAft>
                 <a:spcPts val="800"/>
               </a:spcAft>
-              <a:defRPr sz="1400" b="1">
+              <a:defRPr sz="1350" b="1">
                 <a:solidFill>
                   <a:srgbClr val="34D399"/>
                 </a:solidFill>
+                <a:latin typeface="Segoe UI"/>
               </a:defRPr>
             </a:pPr>
             <a:r>
@@ -4426,10 +4434,11 @@
                 <a:solidFill>
                   <a:srgbClr val="94A3B8"/>
                 </a:solidFill>
+                <a:latin typeface="Segoe UI"/>
               </a:defRPr>
             </a:pPr>
             <a:r>
-              <a:t>gemini-3.8-flash structured fit summary &amp; interview probing flags</a:t>
+              <a:t>gemini-3.8-flash structured fit report, XML fence tags, interview flags</a:t>
             </a:r>
           </a:p>
         </p:txBody>
@@ -4442,8 +4451,8 @@
         </p:nvSpPr>
         <p:spPr>
           <a:xfrm>
-            <a:off x="8933688" y="3840480"/>
-            <a:ext cx="2514600" cy="2011680"/>
+            <a:off x="8933688" y="3520440"/>
+            <a:ext cx="2514600" cy="2194560"/>
           </a:xfrm>
           <a:prstGeom prst="roundRect">
             <a:avLst/>
@@ -4472,17 +4481,18 @@
           </a:fontRef>
         </p:style>
         <p:txBody>
-          <a:bodyPr rtlCol="0" anchor="ctr" wrap="square" lIns="228600" rIns="228600" tIns="182880" bIns="182880"/>
+          <a:bodyPr rtlCol="0" anchor="ctr" wrap="square" lIns="219456" rIns="219456" tIns="182880" bIns="182880"/>
           <a:lstStyle/>
           <a:p>
             <a:pPr algn="ctr">
               <a:spcAft>
                 <a:spcPts val="800"/>
               </a:spcAft>
-              <a:defRPr sz="1400" b="1">
+              <a:defRPr sz="1350" b="1">
                 <a:solidFill>
                   <a:srgbClr val="FBBF24"/>
                 </a:solidFill>
+                <a:latin typeface="Segoe UI"/>
               </a:defRPr>
             </a:pPr>
             <a:r>
@@ -4495,10 +4505,47 @@
                 <a:solidFill>
                   <a:srgbClr val="94A3B8"/>
                 </a:solidFill>
+                <a:latin typeface="Segoe UI"/>
               </a:defRPr>
             </a:pPr>
             <a:r>
               <a:t>75 passing automated tests (65 backend in ~25s, 10 frontend in ~2.8s)</a:t>
+            </a:r>
+          </a:p>
+        </p:txBody>
+      </p:sp>
+      <p:sp>
+        <p:nvSpPr>
+          <p:cNvPr id="10" name="TextBox 9"/>
+          <p:cNvSpPr txBox="1"/>
+          <p:nvPr/>
+        </p:nvSpPr>
+        <p:spPr>
+          <a:xfrm>
+            <a:off x="731520" y="5989320"/>
+            <a:ext cx="10698480" cy="320040"/>
+          </a:xfrm>
+          <a:prstGeom prst="rect">
+            <a:avLst/>
+          </a:prstGeom>
+          <a:noFill/>
+        </p:spPr>
+        <p:txBody>
+          <a:bodyPr wrap="none">
+            <a:spAutoFit/>
+          </a:bodyPr>
+          <a:lstStyle/>
+          <a:p>
+            <a:pPr>
+              <a:defRPr sz="1000">
+                <a:solidFill>
+                  <a:srgbClr val="94A3B8"/>
+                </a:solidFill>
+                <a:latin typeface="Segoe UI"/>
+              </a:defRPr>
+            </a:pPr>
+            <a:r>
+              <a:t>Format: 8-Slide Executive Deck (10-Minute Technical Discussion) | TypeScript Monorepo (Node.js 22 + React 18 + SQLite 3)</a:t>
             </a:r>
           </a:p>
         </p:txBody>
@@ -4572,8 +4619,8 @@
         </p:nvSpPr>
         <p:spPr>
           <a:xfrm>
-            <a:off x="731520" y="365760"/>
-            <a:ext cx="2560320" cy="292608"/>
+            <a:off x="731520" y="384048"/>
+            <a:ext cx="2926080" cy="292608"/>
           </a:xfrm>
           <a:prstGeom prst="roundRect">
             <a:avLst/>
@@ -4610,6 +4657,7 @@
                 <a:solidFill>
                   <a:srgbClr val="38BDF8"/>
                 </a:solidFill>
+                <a:latin typeface="Segoe UI"/>
               </a:defRPr>
             </a:pPr>
             <a:r>
@@ -4626,8 +4674,8 @@
         </p:nvSpPr>
         <p:spPr>
           <a:xfrm>
-            <a:off x="10058400" y="365760"/>
-            <a:ext cx="1401775" cy="292608"/>
+            <a:off x="9601200" y="384048"/>
+            <a:ext cx="1858975" cy="292608"/>
           </a:xfrm>
           <a:prstGeom prst="rect">
             <a:avLst/>
@@ -4645,6 +4693,7 @@
                 <a:solidFill>
                   <a:srgbClr val="94A3B8"/>
                 </a:solidFill>
+                <a:latin typeface="Segoe UI"/>
               </a:defRPr>
             </a:pPr>
             <a:r>
@@ -4661,8 +4710,8 @@
         </p:nvSpPr>
         <p:spPr>
           <a:xfrm>
-            <a:off x="731520" y="713232"/>
-            <a:ext cx="10698480" cy="502920"/>
+            <a:off x="731520" y="731520"/>
+            <a:ext cx="10728655" cy="457200"/>
           </a:xfrm>
           <a:prstGeom prst="rect">
             <a:avLst/>
@@ -4676,14 +4725,15 @@
           <a:lstStyle/>
           <a:p>
             <a:pPr>
-              <a:defRPr sz="2200" b="1">
+              <a:defRPr sz="2100" b="1">
                 <a:solidFill>
                   <a:srgbClr val="F8FAFC"/>
                 </a:solidFill>
+                <a:latin typeface="Segoe UI"/>
               </a:defRPr>
             </a:pPr>
             <a:r>
-              <a:t>The Problem, Scope &amp; Core Assumptions</a:t>
+              <a:t>The Problem, Scope &amp; Core Architectural Assumptions</a:t>
             </a:r>
           </a:p>
         </p:txBody>
@@ -4696,8 +4746,8 @@
         </p:nvSpPr>
         <p:spPr>
           <a:xfrm>
-            <a:off x="731520" y="1243584"/>
-            <a:ext cx="10698480" cy="320040"/>
+            <a:off x="731520" y="1207008"/>
+            <a:ext cx="10728655" cy="320040"/>
           </a:xfrm>
           <a:prstGeom prst="rect">
             <a:avLst/>
@@ -4711,10 +4761,11 @@
           <a:lstStyle/>
           <a:p>
             <a:pPr>
-              <a:defRPr sz="1200">
+              <a:defRPr sz="1150">
                 <a:solidFill>
                   <a:srgbClr val="94A3B8"/>
                 </a:solidFill>
+                <a:latin typeface="Segoe UI"/>
               </a:defRPr>
             </a:pPr>
             <a:r>
@@ -4731,8 +4782,8 @@
         </p:nvSpPr>
         <p:spPr>
           <a:xfrm>
-            <a:off x="731520" y="1691640"/>
-            <a:ext cx="5212080" cy="4480560"/>
+            <a:off x="731520" y="1645920"/>
+            <a:ext cx="5212080" cy="4754880"/>
           </a:xfrm>
           <a:prstGeom prst="roundRect">
             <a:avLst/>
@@ -4761,17 +4812,18 @@
           </a:fontRef>
         </p:style>
         <p:txBody>
-          <a:bodyPr rtlCol="0" anchor="ctr" wrap="square" lIns="228600" rIns="228600" tIns="182880" bIns="182880"/>
+          <a:bodyPr rtlCol="0" anchor="ctr" wrap="square" lIns="219456" rIns="219456" tIns="182880" bIns="182880"/>
           <a:lstStyle/>
           <a:p>
             <a:pPr algn="ctr">
               <a:spcAft>
                 <a:spcPts val="800"/>
               </a:spcAft>
-              <a:defRPr sz="1400" b="1">
+              <a:defRPr sz="1350" b="1">
                 <a:solidFill>
                   <a:srgbClr val="38BDF8"/>
                 </a:solidFill>
+                <a:latin typeface="Segoe UI"/>
               </a:defRPr>
             </a:pPr>
             <a:r>
@@ -4781,22 +4833,24 @@
           <a:p>
             <a:pPr>
               <a:spcAft>
-                <a:spcPts val="600"/>
+                <a:spcPts val="550"/>
               </a:spcAft>
             </a:pPr>
             <a:r>
-              <a:rPr b="1" sz="1100">
+              <a:rPr b="1" sz="1050">
                 <a:solidFill>
                   <a:srgbClr val="F8FAFC"/>
                 </a:solidFill>
+                <a:latin typeface="Segoe UI"/>
               </a:rPr>
               <a:t>The Problem: </a:t>
             </a:r>
             <a:r>
-              <a:rPr sz="1100">
+              <a:rPr sz="1050">
                 <a:solidFill>
                   <a:srgbClr val="94A3B8"/>
                 </a:solidFill>
+                <a:latin typeface="Segoe UI"/>
               </a:rPr>
               <a:t>Recruiters triage hundreds of candidates across static spreadsheets with subjective gut-feel, slow screening cycles, and no persistent decision tracking.</a:t>
             </a:r>
@@ -4804,45 +4858,49 @@
           <a:p>
             <a:pPr>
               <a:spcAft>
-                <a:spcPts val="600"/>
+                <a:spcPts val="550"/>
               </a:spcAft>
             </a:pPr>
             <a:r>
-              <a:rPr b="1" sz="1100">
+              <a:rPr b="1" sz="1050">
                 <a:solidFill>
                   <a:srgbClr val="F8FAFC"/>
                 </a:solidFill>
+                <a:latin typeface="Segoe UI"/>
               </a:rPr>
               <a:t>Full-Stack Dashboard: </a:t>
             </a:r>
             <a:r>
-              <a:rPr sz="1100">
+              <a:rPr sz="1050">
                 <a:solidFill>
                   <a:srgbClr val="94A3B8"/>
                 </a:solidFill>
-              </a:rPr>
-              <a:t>Provide interactive multi-criteria filtering, debounced search, and immediate triage mutations (Untriaged -&gt; Shortlisted / Rejected).</a:t>
+                <a:latin typeface="Segoe UI"/>
+              </a:rPr>
+              <a:t>Provide interactive multi-criteria filtering, debounced search, and immediate triage status mutations (Untriaged -&gt; Shortlisted / Rejected).</a:t>
             </a:r>
           </a:p>
           <a:p>
             <a:pPr>
               <a:spcAft>
-                <a:spcPts val="600"/>
+                <a:spcPts val="550"/>
               </a:spcAft>
             </a:pPr>
             <a:r>
-              <a:rPr b="1" sz="1100">
+              <a:rPr b="1" sz="1050">
                 <a:solidFill>
                   <a:srgbClr val="F8FAFC"/>
                 </a:solidFill>
+                <a:latin typeface="Segoe UI"/>
               </a:rPr>
               <a:t>Normalized Persistence: </a:t>
             </a:r>
             <a:r>
-              <a:rPr sz="1100">
+              <a:rPr sz="1050">
                 <a:solidFill>
                   <a:srgbClr val="94A3B8"/>
                 </a:solidFill>
+                <a:latin typeface="Segoe UI"/>
               </a:rPr>
               <a:t>Implement a relational SQLite backend that persists recruiter actions non-destructively across server restarts.</a:t>
             </a:r>
@@ -4850,22 +4908,24 @@
           <a:p>
             <a:pPr>
               <a:spcAft>
-                <a:spcPts val="600"/>
+                <a:spcPts val="550"/>
               </a:spcAft>
             </a:pPr>
             <a:r>
-              <a:rPr b="1" sz="1100">
+              <a:rPr b="1" sz="1050">
                 <a:solidFill>
                   <a:srgbClr val="F8FAFC"/>
                 </a:solidFill>
+                <a:latin typeface="Segoe UI"/>
               </a:rPr>
               <a:t>Targeted AI Feature: </a:t>
             </a:r>
             <a:r>
-              <a:rPr sz="1100">
+              <a:rPr sz="1050">
                 <a:solidFill>
                   <a:srgbClr val="94A3B8"/>
                 </a:solidFill>
+                <a:latin typeface="Segoe UI"/>
               </a:rPr>
               <a:t>Integrate exactly ONE high-value LLM capability rather than scattered gimmicks.</a:t>
             </a:r>
@@ -4873,22 +4933,24 @@
           <a:p>
             <a:pPr>
               <a:spcAft>
-                <a:spcPts val="600"/>
+                <a:spcPts val="550"/>
               </a:spcAft>
             </a:pPr>
             <a:r>
-              <a:rPr b="1" sz="1100">
+              <a:rPr b="1" sz="1050">
                 <a:solidFill>
                   <a:srgbClr val="F8FAFC"/>
                 </a:solidFill>
+                <a:latin typeface="Segoe UI"/>
               </a:rPr>
               <a:t>Scalable Ranking: </a:t>
             </a:r>
             <a:r>
-              <a:rPr sz="1100">
+              <a:rPr sz="1050">
                 <a:solidFill>
                   <a:srgbClr val="94A3B8"/>
                 </a:solidFill>
+                <a:latin typeface="Segoe UI"/>
               </a:rPr>
               <a:t>Implement and evaluate deterministic candidate ranking across a 100,000 synthetic candidate benchmark.</a:t>
             </a:r>
@@ -4903,8 +4965,8 @@
         </p:nvSpPr>
         <p:spPr>
           <a:xfrm>
-            <a:off x="6217920" y="1691640"/>
-            <a:ext cx="5212080" cy="4480560"/>
+            <a:off x="6217920" y="1645920"/>
+            <a:ext cx="5212080" cy="4754880"/>
           </a:xfrm>
           <a:prstGeom prst="roundRect">
             <a:avLst/>
@@ -4933,17 +4995,18 @@
           </a:fontRef>
         </p:style>
         <p:txBody>
-          <a:bodyPr rtlCol="0" anchor="ctr" wrap="square" lIns="228600" rIns="228600" tIns="182880" bIns="182880"/>
+          <a:bodyPr rtlCol="0" anchor="ctr" wrap="square" lIns="219456" rIns="219456" tIns="182880" bIns="182880"/>
           <a:lstStyle/>
           <a:p>
             <a:pPr algn="ctr">
               <a:spcAft>
                 <a:spcPts val="800"/>
               </a:spcAft>
-              <a:defRPr sz="1400" b="1">
+              <a:defRPr sz="1350" b="1">
                 <a:solidFill>
                   <a:srgbClr val="818CF8"/>
                 </a:solidFill>
+                <a:latin typeface="Segoe UI"/>
               </a:defRPr>
             </a:pPr>
             <a:r>
@@ -4953,22 +5016,24 @@
           <a:p>
             <a:pPr>
               <a:spcAft>
-                <a:spcPts val="600"/>
+                <a:spcPts val="550"/>
               </a:spcAft>
             </a:pPr>
             <a:r>
-              <a:rPr b="1" sz="1100">
+              <a:rPr b="1" sz="1050">
                 <a:solidFill>
                   <a:srgbClr val="F8FAFC"/>
                 </a:solidFill>
+                <a:latin typeface="Segoe UI"/>
               </a:rPr>
               <a:t>Non-Destructive Seeding: </a:t>
             </a:r>
             <a:r>
-              <a:rPr sz="1100">
+              <a:rPr sz="1050">
                 <a:solidFill>
                   <a:srgbClr val="94A3B8"/>
                 </a:solidFill>
+                <a:latin typeface="Segoe UI"/>
               </a:rPr>
               <a:t>Re-seeding SQLite from JSON must update biographical data on conflict but deliberately omit the status column, preserving recruiter decisions across restarts.</a:t>
             </a:r>
@@ -4976,22 +5041,24 @@
           <a:p>
             <a:pPr>
               <a:spcAft>
-                <a:spcPts val="600"/>
+                <a:spcPts val="550"/>
               </a:spcAft>
             </a:pPr>
             <a:r>
-              <a:rPr b="1" sz="1100">
+              <a:rPr b="1" sz="1050">
                 <a:solidFill>
                   <a:srgbClr val="F8FAFC"/>
                 </a:solidFill>
+                <a:latin typeface="Segoe UI"/>
               </a:rPr>
               <a:t>3NF Relational Modeling: </a:t>
             </a:r>
             <a:r>
-              <a:rPr sz="1100">
+              <a:rPr sz="1050">
                 <a:solidFill>
                   <a:srgbClr val="94A3B8"/>
                 </a:solidFill>
+                <a:latin typeface="Segoe UI"/>
               </a:rPr>
               <a:t>Normalize candidate skills into a dictionary and many-to-many junction table to guarantee relational integrity, eliminate duplicate tags, and support fast indexed queries.</a:t>
             </a:r>
@@ -4999,22 +5066,24 @@
           <a:p>
             <a:pPr>
               <a:spcAft>
-                <a:spcPts val="600"/>
+                <a:spcPts val="550"/>
               </a:spcAft>
             </a:pPr>
             <a:r>
-              <a:rPr b="1" sz="1100">
+              <a:rPr b="1" sz="1050">
                 <a:solidFill>
                   <a:srgbClr val="F8FAFC"/>
                 </a:solidFill>
+                <a:latin typeface="Segoe UI"/>
               </a:rPr>
               <a:t>High-Leverage AI Value: </a:t>
             </a:r>
             <a:r>
-              <a:rPr sz="1100">
+              <a:rPr sz="1050">
                 <a:solidFill>
                   <a:srgbClr val="94A3B8"/>
                 </a:solidFill>
+                <a:latin typeface="Segoe UI"/>
               </a:rPr>
               <a:t>Evidence-grounded candidate-fit evaluation against recruiter job descriptions delivers 10x higher triage value than generic semantic search over 48 mock candidates.</a:t>
             </a:r>
@@ -5022,22 +5091,24 @@
           <a:p>
             <a:pPr>
               <a:spcAft>
-                <a:spcPts val="600"/>
+                <a:spcPts val="550"/>
               </a:spcAft>
             </a:pPr>
             <a:r>
-              <a:rPr b="1" sz="1100">
+              <a:rPr b="1" sz="1050">
                 <a:solidFill>
                   <a:srgbClr val="F8FAFC"/>
                 </a:solidFill>
+                <a:latin typeface="Segoe UI"/>
               </a:rPr>
               <a:t>Zero External Test Calls: </a:t>
             </a:r>
             <a:r>
-              <a:rPr sz="1100">
+              <a:rPr sz="1050">
                 <a:solidFill>
                   <a:srgbClr val="94A3B8"/>
                 </a:solidFill>
+                <a:latin typeface="Segoe UI"/>
               </a:rPr>
               <a:t>Automated test suites must run 100% deterministically with mocked provider responses to avoid token costs and internet dependencies.</a:t>
             </a:r>
@@ -5113,8 +5184,8 @@
         </p:nvSpPr>
         <p:spPr>
           <a:xfrm>
-            <a:off x="731520" y="365760"/>
-            <a:ext cx="2560320" cy="292608"/>
+            <a:off x="731520" y="384048"/>
+            <a:ext cx="2926080" cy="292608"/>
           </a:xfrm>
           <a:prstGeom prst="roundRect">
             <a:avLst/>
@@ -5151,6 +5222,7 @@
                 <a:solidFill>
                   <a:srgbClr val="38BDF8"/>
                 </a:solidFill>
+                <a:latin typeface="Segoe UI"/>
               </a:defRPr>
             </a:pPr>
             <a:r>
@@ -5167,8 +5239,8 @@
         </p:nvSpPr>
         <p:spPr>
           <a:xfrm>
-            <a:off x="10058400" y="365760"/>
-            <a:ext cx="1401775" cy="292608"/>
+            <a:off x="9601200" y="384048"/>
+            <a:ext cx="1858975" cy="292608"/>
           </a:xfrm>
           <a:prstGeom prst="rect">
             <a:avLst/>
@@ -5186,6 +5258,7 @@
                 <a:solidFill>
                   <a:srgbClr val="94A3B8"/>
                 </a:solidFill>
+                <a:latin typeface="Segoe UI"/>
               </a:defRPr>
             </a:pPr>
             <a:r>
@@ -5202,8 +5275,8 @@
         </p:nvSpPr>
         <p:spPr>
           <a:xfrm>
-            <a:off x="731520" y="713232"/>
-            <a:ext cx="10698480" cy="502920"/>
+            <a:off x="731520" y="731520"/>
+            <a:ext cx="10728655" cy="457200"/>
           </a:xfrm>
           <a:prstGeom prst="rect">
             <a:avLst/>
@@ -5217,10 +5290,11 @@
           <a:lstStyle/>
           <a:p>
             <a:pPr>
-              <a:defRPr sz="2200" b="1">
+              <a:defRPr sz="2100" b="1">
                 <a:solidFill>
                   <a:srgbClr val="F8FAFC"/>
                 </a:solidFill>
+                <a:latin typeface="Segoe UI"/>
               </a:defRPr>
             </a:pPr>
             <a:r>
@@ -5237,8 +5311,8 @@
         </p:nvSpPr>
         <p:spPr>
           <a:xfrm>
-            <a:off x="731520" y="1243584"/>
-            <a:ext cx="10698480" cy="320040"/>
+            <a:off x="731520" y="1207008"/>
+            <a:ext cx="10728655" cy="320040"/>
           </a:xfrm>
           <a:prstGeom prst="rect">
             <a:avLst/>
@@ -5252,10 +5326,11 @@
           <a:lstStyle/>
           <a:p>
             <a:pPr>
-              <a:defRPr sz="1200">
+              <a:defRPr sz="1150">
                 <a:solidFill>
                   <a:srgbClr val="94A3B8"/>
                 </a:solidFill>
+                <a:latin typeface="Segoe UI"/>
               </a:defRPr>
             </a:pPr>
             <a:r>
@@ -5272,8 +5347,8 @@
         </p:nvSpPr>
         <p:spPr>
           <a:xfrm>
-            <a:off x="731520" y="1691640"/>
-            <a:ext cx="5212080" cy="2834640"/>
+            <a:off x="731520" y="1645920"/>
+            <a:ext cx="5212080" cy="2971800"/>
           </a:xfrm>
           <a:prstGeom prst="roundRect">
             <a:avLst/>
@@ -5302,17 +5377,18 @@
           </a:fontRef>
         </p:style>
         <p:txBody>
-          <a:bodyPr rtlCol="0" anchor="ctr" wrap="square" lIns="228600" rIns="228600" tIns="182880" bIns="182880"/>
+          <a:bodyPr rtlCol="0" anchor="ctr" wrap="square" lIns="219456" rIns="219456" tIns="182880" bIns="182880"/>
           <a:lstStyle/>
           <a:p>
             <a:pPr algn="ctr">
               <a:spcAft>
                 <a:spcPts val="800"/>
               </a:spcAft>
-              <a:defRPr sz="1400" b="1">
+              <a:defRPr sz="1350" b="1">
                 <a:solidFill>
                   <a:srgbClr val="38BDF8"/>
                 </a:solidFill>
+                <a:latin typeface="Segoe UI"/>
               </a:defRPr>
             </a:pPr>
             <a:r>
@@ -5322,22 +5398,24 @@
           <a:p>
             <a:pPr>
               <a:spcAft>
-                <a:spcPts val="600"/>
+                <a:spcPts val="550"/>
               </a:spcAft>
             </a:pPr>
             <a:r>
-              <a:rPr b="1" sz="1100">
+              <a:rPr b="1" sz="1050">
                 <a:solidFill>
                   <a:srgbClr val="F8FAFC"/>
                 </a:solidFill>
+                <a:latin typeface="Segoe UI"/>
               </a:rPr>
               <a:t>Frontend Workspace: </a:t>
             </a:r>
             <a:r>
-              <a:rPr sz="1100">
+              <a:rPr sz="1050">
                 <a:solidFill>
                   <a:srgbClr val="94A3B8"/>
                 </a:solidFill>
+                <a:latin typeface="Segoe UI"/>
               </a:rPr>
               <a:t>React 18 + Vite with accessibility-conscious styling, debounced filtering, KPI metrics, and slide-out candidate details drawer.</a:t>
             </a:r>
@@ -5345,22 +5423,24 @@
           <a:p>
             <a:pPr>
               <a:spcAft>
-                <a:spcPts val="600"/>
+                <a:spcPts val="550"/>
               </a:spcAft>
             </a:pPr>
             <a:r>
-              <a:rPr b="1" sz="1100">
+              <a:rPr b="1" sz="1050">
                 <a:solidFill>
                   <a:srgbClr val="F8FAFC"/>
                 </a:solidFill>
+                <a:latin typeface="Segoe UI"/>
               </a:rPr>
               <a:t>Backend Workspace: </a:t>
             </a:r>
             <a:r>
-              <a:rPr sz="1100">
+              <a:rPr sz="1050">
                 <a:solidFill>
                   <a:srgbClr val="94A3B8"/>
                 </a:solidFill>
+                <a:latin typeface="Segoe UI"/>
               </a:rPr>
               <a:t>Express 4 + Node.js 22 with dependency-injected database and Gemini AI service layers.</a:t>
             </a:r>
@@ -5368,22 +5448,24 @@
           <a:p>
             <a:pPr>
               <a:spcAft>
-                <a:spcPts val="600"/>
+                <a:spcPts val="550"/>
               </a:spcAft>
             </a:pPr>
             <a:r>
-              <a:rPr b="1" sz="1100">
+              <a:rPr b="1" sz="1050">
                 <a:solidFill>
                   <a:srgbClr val="F8FAFC"/>
                 </a:solidFill>
+                <a:latin typeface="Segoe UI"/>
               </a:rPr>
               <a:t>Defensive Validation: </a:t>
             </a:r>
             <a:r>
-              <a:rPr sz="1100">
+              <a:rPr sz="1050">
                 <a:solidFill>
                   <a:srgbClr val="94A3B8"/>
                 </a:solidFill>
+                <a:latin typeface="Segoe UI"/>
               </a:rPr>
               <a:t>Cross-parameter range checks (min_experience &lt;= max_experience), pagination bounds, and consistent error envelopes ({ error: { code, message } }).</a:t>
             </a:r>
@@ -5398,8 +5480,8 @@
         </p:nvSpPr>
         <p:spPr>
           <a:xfrm>
-            <a:off x="6217920" y="1691640"/>
-            <a:ext cx="5212080" cy="2834640"/>
+            <a:off x="6217920" y="1645920"/>
+            <a:ext cx="5212080" cy="2971800"/>
           </a:xfrm>
           <a:prstGeom prst="roundRect">
             <a:avLst/>
@@ -5428,17 +5510,18 @@
           </a:fontRef>
         </p:style>
         <p:txBody>
-          <a:bodyPr rtlCol="0" anchor="ctr" wrap="square" lIns="228600" rIns="228600" tIns="182880" bIns="182880"/>
+          <a:bodyPr rtlCol="0" anchor="ctr" wrap="square" lIns="219456" rIns="219456" tIns="182880" bIns="182880"/>
           <a:lstStyle/>
           <a:p>
             <a:pPr algn="ctr">
               <a:spcAft>
                 <a:spcPts val="800"/>
               </a:spcAft>
-              <a:defRPr sz="1400" b="1">
+              <a:defRPr sz="1350" b="1">
                 <a:solidFill>
                   <a:srgbClr val="818CF8"/>
                 </a:solidFill>
+                <a:latin typeface="Segoe UI"/>
               </a:defRPr>
             </a:pPr>
             <a:r>
@@ -5448,22 +5531,24 @@
           <a:p>
             <a:pPr>
               <a:spcAft>
-                <a:spcPts val="600"/>
+                <a:spcPts val="550"/>
               </a:spcAft>
             </a:pPr>
             <a:r>
-              <a:rPr b="1" sz="1100">
+              <a:rPr b="1" sz="1050">
                 <a:solidFill>
                   <a:srgbClr val="F8FAFC"/>
                 </a:solidFill>
+                <a:latin typeface="Segoe UI"/>
               </a:rPr>
               <a:t>candidates Table: </a:t>
             </a:r>
             <a:r>
-              <a:rPr sz="1100">
+              <a:rPr sz="1050">
                 <a:solidFill>
                   <a:srgbClr val="94A3B8"/>
                 </a:solidFill>
+                <a:latin typeface="Segoe UI"/>
               </a:rPr>
               <a:t>Core biographical data, years experience, source, notes, applied date, and persistent triage status.</a:t>
             </a:r>
@@ -5471,22 +5556,24 @@
           <a:p>
             <a:pPr>
               <a:spcAft>
-                <a:spcPts val="600"/>
+                <a:spcPts val="550"/>
               </a:spcAft>
             </a:pPr>
             <a:r>
-              <a:rPr b="1" sz="1100">
+              <a:rPr b="1" sz="1050">
                 <a:solidFill>
                   <a:srgbClr val="F8FAFC"/>
                 </a:solidFill>
+                <a:latin typeface="Segoe UI"/>
               </a:rPr>
               <a:t>skills Table: </a:t>
             </a:r>
             <a:r>
-              <a:rPr sz="1100">
+              <a:rPr sz="1050">
                 <a:solidFill>
                   <a:srgbClr val="94A3B8"/>
                 </a:solidFill>
+                <a:latin typeface="Segoe UI"/>
               </a:rPr>
               <a:t>Global dictionary of unique technical skills with NOCASE unique constraints.</a:t>
             </a:r>
@@ -5494,22 +5581,24 @@
           <a:p>
             <a:pPr>
               <a:spcAft>
-                <a:spcPts val="600"/>
+                <a:spcPts val="550"/>
               </a:spcAft>
             </a:pPr>
             <a:r>
-              <a:rPr b="1" sz="1100">
+              <a:rPr b="1" sz="1050">
                 <a:solidFill>
                   <a:srgbClr val="F8FAFC"/>
                 </a:solidFill>
+                <a:latin typeface="Segoe UI"/>
               </a:rPr>
               <a:t>candidate_skills Table: </a:t>
             </a:r>
             <a:r>
-              <a:rPr sz="1100">
+              <a:rPr sz="1050">
                 <a:solidFill>
                   <a:srgbClr val="94A3B8"/>
                 </a:solidFill>
+                <a:latin typeface="Segoe UI"/>
               </a:rPr>
               <a:t>Many-to-many junction table with cascade deletion and foreign keys (cleaned on re-seed).</a:t>
             </a:r>
@@ -5517,22 +5606,24 @@
           <a:p>
             <a:pPr>
               <a:spcAft>
-                <a:spcPts val="600"/>
+                <a:spcPts val="550"/>
               </a:spcAft>
             </a:pPr>
             <a:r>
-              <a:rPr b="1" sz="1100">
+              <a:rPr b="1" sz="1050">
                 <a:solidFill>
                   <a:srgbClr val="F8FAFC"/>
                 </a:solidFill>
+                <a:latin typeface="Segoe UI"/>
               </a:rPr>
               <a:t>B-Tree Indexes: </a:t>
             </a:r>
             <a:r>
-              <a:rPr sz="1100">
+              <a:rPr sz="1050">
                 <a:solidFill>
                   <a:srgbClr val="94A3B8"/>
                 </a:solidFill>
+                <a:latin typeface="Segoe UI"/>
               </a:rPr>
               <a:t>Targeted indexes on status, target_role, source, years_experience, and applied_date.</a:t>
             </a:r>
@@ -5547,8 +5638,8 @@
         </p:nvSpPr>
         <p:spPr>
           <a:xfrm>
-            <a:off x="731520" y="4709160"/>
-            <a:ext cx="10698480" cy="1463040"/>
+            <a:off x="731520" y="4754880"/>
+            <a:ext cx="10698480" cy="1645920"/>
           </a:xfrm>
           <a:prstGeom prst="roundRect">
             <a:avLst/>
@@ -5577,17 +5668,18 @@
           </a:fontRef>
         </p:style>
         <p:txBody>
-          <a:bodyPr rtlCol="0" anchor="ctr" wrap="square" lIns="228600" rIns="228600" tIns="182880" bIns="182880"/>
+          <a:bodyPr rtlCol="0" anchor="ctr" wrap="square" lIns="219456" rIns="219456" tIns="182880" bIns="182880"/>
           <a:lstStyle/>
           <a:p>
             <a:pPr algn="ctr">
               <a:spcAft>
                 <a:spcPts val="800"/>
               </a:spcAft>
-              <a:defRPr sz="1400" b="1">
+              <a:defRPr sz="1350" b="1">
                 <a:solidFill>
                   <a:srgbClr val="34D399"/>
                 </a:solidFill>
+                <a:latin typeface="Segoe UI"/>
               </a:defRPr>
             </a:pPr>
             <a:r>
@@ -5597,22 +5689,24 @@
           <a:p>
             <a:pPr>
               <a:spcAft>
-                <a:spcPts val="600"/>
+                <a:spcPts val="550"/>
               </a:spcAft>
             </a:pPr>
             <a:r>
-              <a:rPr b="1" sz="1100">
+              <a:rPr b="1" sz="1050">
                 <a:solidFill>
                   <a:srgbClr val="F8FAFC"/>
                 </a:solidFill>
+                <a:latin typeface="Segoe UI"/>
               </a:rPr>
               <a:t>GET /api/candidates: </a:t>
             </a:r>
             <a:r>
-              <a:rPr sz="1100">
+              <a:rPr sz="1050">
                 <a:solidFill>
                   <a:srgbClr val="94A3B8"/>
                 </a:solidFill>
+                <a:latin typeface="Segoe UI"/>
               </a:rPr>
               <a:t>Paginated search and filtering with SQL parameters and SQL-injection-safe queries.</a:t>
             </a:r>
@@ -5620,22 +5714,24 @@
           <a:p>
             <a:pPr>
               <a:spcAft>
-                <a:spcPts val="600"/>
+                <a:spcPts val="550"/>
               </a:spcAft>
             </a:pPr>
             <a:r>
-              <a:rPr b="1" sz="1100">
+              <a:rPr b="1" sz="1050">
                 <a:solidFill>
                   <a:srgbClr val="F8FAFC"/>
                 </a:solidFill>
+                <a:latin typeface="Segoe UI"/>
               </a:rPr>
               <a:t>GET /api/stats: </a:t>
             </a:r>
             <a:r>
-              <a:rPr sz="1100">
+              <a:rPr sz="1050">
                 <a:solidFill>
                   <a:srgbClr val="94A3B8"/>
                 </a:solidFill>
+                <a:latin typeface="Segoe UI"/>
               </a:rPr>
               <a:t>Aggregate triage counts (Total, Untriaged, Shortlisted, Rejected) via a single GROUP BY query.</a:t>
             </a:r>
@@ -5643,22 +5739,24 @@
           <a:p>
             <a:pPr>
               <a:spcAft>
-                <a:spcPts val="600"/>
+                <a:spcPts val="550"/>
               </a:spcAft>
             </a:pPr>
             <a:r>
-              <a:rPr b="1" sz="1100">
+              <a:rPr b="1" sz="1050">
                 <a:solidFill>
                   <a:srgbClr val="F8FAFC"/>
                 </a:solidFill>
+                <a:latin typeface="Segoe UI"/>
               </a:rPr>
               <a:t>GET /api/roles &amp; /sources: </a:t>
             </a:r>
             <a:r>
-              <a:rPr sz="1100">
+              <a:rPr sz="1050">
                 <a:solidFill>
                   <a:srgbClr val="94A3B8"/>
                 </a:solidFill>
+                <a:latin typeface="Segoe UI"/>
               </a:rPr>
               <a:t>Distinct filter discovery endpoints eliminating full candidate sampling.</a:t>
             </a:r>
@@ -5666,22 +5764,24 @@
           <a:p>
             <a:pPr>
               <a:spcAft>
-                <a:spcPts val="600"/>
+                <a:spcPts val="550"/>
               </a:spcAft>
             </a:pPr>
             <a:r>
-              <a:rPr b="1" sz="1100">
+              <a:rPr b="1" sz="1050">
                 <a:solidFill>
                   <a:srgbClr val="F8FAFC"/>
                 </a:solidFill>
+                <a:latin typeface="Segoe UI"/>
               </a:rPr>
               <a:t>PATCH /api/candidates/:id/status &amp; POST /api/ai/candidate-fit: </a:t>
             </a:r>
             <a:r>
-              <a:rPr sz="1100">
+              <a:rPr sz="1050">
                 <a:solidFill>
                   <a:srgbClr val="94A3B8"/>
                 </a:solidFill>
+                <a:latin typeface="Segoe UI"/>
               </a:rPr>
               <a:t>Instant triage state updates and grounded Gemini fit evaluations.</a:t>
             </a:r>
@@ -5757,8 +5857,8 @@
         </p:nvSpPr>
         <p:spPr>
           <a:xfrm>
-            <a:off x="731520" y="365760"/>
-            <a:ext cx="2560320" cy="292608"/>
+            <a:off x="731520" y="384048"/>
+            <a:ext cx="2926080" cy="292608"/>
           </a:xfrm>
           <a:prstGeom prst="roundRect">
             <a:avLst/>
@@ -5795,6 +5895,7 @@
                 <a:solidFill>
                   <a:srgbClr val="38BDF8"/>
                 </a:solidFill>
+                <a:latin typeface="Segoe UI"/>
               </a:defRPr>
             </a:pPr>
             <a:r>
@@ -5811,8 +5912,8 @@
         </p:nvSpPr>
         <p:spPr>
           <a:xfrm>
-            <a:off x="10058400" y="365760"/>
-            <a:ext cx="1401775" cy="292608"/>
+            <a:off x="9601200" y="384048"/>
+            <a:ext cx="1858975" cy="292608"/>
           </a:xfrm>
           <a:prstGeom prst="rect">
             <a:avLst/>
@@ -5830,6 +5931,7 @@
                 <a:solidFill>
                   <a:srgbClr val="94A3B8"/>
                 </a:solidFill>
+                <a:latin typeface="Segoe UI"/>
               </a:defRPr>
             </a:pPr>
             <a:r>
@@ -5846,8 +5948,8 @@
         </p:nvSpPr>
         <p:spPr>
           <a:xfrm>
-            <a:off x="731520" y="713232"/>
-            <a:ext cx="10698480" cy="502920"/>
+            <a:off x="731520" y="731520"/>
+            <a:ext cx="10728655" cy="457200"/>
           </a:xfrm>
           <a:prstGeom prst="rect">
             <a:avLst/>
@@ -5861,10 +5963,11 @@
           <a:lstStyle/>
           <a:p>
             <a:pPr>
-              <a:defRPr sz="2200" b="1">
+              <a:defRPr sz="2100" b="1">
                 <a:solidFill>
                   <a:srgbClr val="F8FAFC"/>
                 </a:solidFill>
+                <a:latin typeface="Segoe UI"/>
               </a:defRPr>
             </a:pPr>
             <a:r>
@@ -5881,8 +5984,8 @@
         </p:nvSpPr>
         <p:spPr>
           <a:xfrm>
-            <a:off x="731520" y="1243584"/>
-            <a:ext cx="10698480" cy="320040"/>
+            <a:off x="731520" y="1207008"/>
+            <a:ext cx="10728655" cy="320040"/>
           </a:xfrm>
           <a:prstGeom prst="rect">
             <a:avLst/>
@@ -5896,10 +5999,11 @@
           <a:lstStyle/>
           <a:p>
             <a:pPr>
-              <a:defRPr sz="1200">
+              <a:defRPr sz="1150">
                 <a:solidFill>
                   <a:srgbClr val="94A3B8"/>
                 </a:solidFill>
+                <a:latin typeface="Segoe UI"/>
               </a:defRPr>
             </a:pPr>
             <a:r>
@@ -5916,8 +6020,8 @@
         </p:nvSpPr>
         <p:spPr>
           <a:xfrm>
-            <a:off x="731520" y="1691640"/>
-            <a:ext cx="5212080" cy="2926080"/>
+            <a:off x="731520" y="1645920"/>
+            <a:ext cx="5212080" cy="2971800"/>
           </a:xfrm>
           <a:prstGeom prst="roundRect">
             <a:avLst/>
@@ -5946,17 +6050,18 @@
           </a:fontRef>
         </p:style>
         <p:txBody>
-          <a:bodyPr rtlCol="0" anchor="ctr" wrap="square" lIns="228600" rIns="228600" tIns="182880" bIns="182880"/>
+          <a:bodyPr rtlCol="0" anchor="ctr" wrap="square" lIns="219456" rIns="219456" tIns="182880" bIns="182880"/>
           <a:lstStyle/>
           <a:p>
             <a:pPr algn="ctr">
               <a:spcAft>
                 <a:spcPts val="800"/>
               </a:spcAft>
-              <a:defRPr sz="1400" b="1">
+              <a:defRPr sz="1350" b="1">
                 <a:solidFill>
                   <a:srgbClr val="38BDF8"/>
                 </a:solidFill>
+                <a:latin typeface="Segoe UI"/>
               </a:defRPr>
             </a:pPr>
             <a:r>
@@ -5966,22 +6071,24 @@
           <a:p>
             <a:pPr>
               <a:spcAft>
-                <a:spcPts val="600"/>
+                <a:spcPts val="550"/>
               </a:spcAft>
             </a:pPr>
             <a:r>
-              <a:rPr b="1" sz="1100">
+              <a:rPr b="1" sz="1050">
                 <a:solidFill>
                   <a:srgbClr val="F8FAFC"/>
                 </a:solidFill>
+                <a:latin typeface="Segoe UI"/>
               </a:rPr>
               <a:t>Problem Mandate: </a:t>
             </a:r>
             <a:r>
-              <a:rPr sz="1100">
+              <a:rPr sz="1050">
                 <a:solidFill>
                   <a:srgbClr val="94A3B8"/>
                 </a:solidFill>
+                <a:latin typeface="Segoe UI"/>
               </a:rPr>
               <a:t>Rank 100,000 candidates by distinct required skill overlap with deterministic tie-breaking.</a:t>
             </a:r>
@@ -5989,22 +6096,24 @@
           <a:p>
             <a:pPr>
               <a:spcAft>
-                <a:spcPts val="600"/>
+                <a:spcPts val="550"/>
               </a:spcAft>
             </a:pPr>
             <a:r>
-              <a:rPr b="1" sz="1100">
+              <a:rPr b="1" sz="1050">
                 <a:solidFill>
                   <a:srgbClr val="F8FAFC"/>
                 </a:solidFill>
+                <a:latin typeface="Segoe UI"/>
               </a:rPr>
               <a:t>Skill Intersection: </a:t>
             </a:r>
             <a:r>
-              <a:rPr sz="1100">
+              <a:rPr sz="1050">
                 <a:solidFill>
                   <a:srgbClr val="94A3B8"/>
                 </a:solidFill>
+                <a:latin typeface="Segoe UI"/>
               </a:rPr>
               <a:t>Distinct set matching: duplicate candidate or query skills never inflate match scores.</a:t>
             </a:r>
@@ -6012,22 +6121,24 @@
           <a:p>
             <a:pPr>
               <a:spcAft>
-                <a:spcPts val="600"/>
+                <a:spcPts val="550"/>
               </a:spcAft>
             </a:pPr>
             <a:r>
-              <a:rPr b="1" sz="1100">
+              <a:rPr b="1" sz="1050">
                 <a:solidFill>
                   <a:srgbClr val="F8FAFC"/>
                 </a:solidFill>
+                <a:latin typeface="Segoe UI"/>
               </a:rPr>
               <a:t>Bucket Partitioning: </a:t>
             </a:r>
             <a:r>
-              <a:rPr sz="1100">
+              <a:rPr sz="1050">
                 <a:solidFill>
                   <a:srgbClr val="94A3B8"/>
                 </a:solidFill>
+                <a:latin typeface="Segoe UI"/>
               </a:rPr>
               <a:t>Partitions candidates into R+1 score buckets in O(N * S_c) linear time.</a:t>
             </a:r>
@@ -6035,22 +6146,24 @@
           <a:p>
             <a:pPr>
               <a:spcAft>
-                <a:spcPts val="600"/>
+                <a:spcPts val="550"/>
               </a:spcAft>
             </a:pPr>
             <a:r>
-              <a:rPr b="1" sz="1100">
+              <a:rPr b="1" sz="1050">
                 <a:solidFill>
                   <a:srgbClr val="F8FAFC"/>
                 </a:solidFill>
+                <a:latin typeface="Segoe UI"/>
               </a:rPr>
               <a:t>Deterministic Tie-Breaker: </a:t>
             </a:r>
             <a:r>
-              <a:rPr sz="1100">
+              <a:rPr sz="1050">
                 <a:solidFill>
                   <a:srgbClr val="94A3B8"/>
                 </a:solidFill>
+                <a:latin typeface="Segoe UI"/>
               </a:rPr>
               <a:t>Score (desc) -&gt; Experience (desc) -&gt; Name (asc) -&gt; ID (asc).</a:t>
             </a:r>
@@ -6065,8 +6178,8 @@
         </p:nvSpPr>
         <p:spPr>
           <a:xfrm>
-            <a:off x="6217920" y="1691640"/>
-            <a:ext cx="5212080" cy="2926080"/>
+            <a:off x="6217920" y="1645920"/>
+            <a:ext cx="5212080" cy="2971800"/>
           </a:xfrm>
           <a:prstGeom prst="roundRect">
             <a:avLst/>
@@ -6095,17 +6208,18 @@
           </a:fontRef>
         </p:style>
         <p:txBody>
-          <a:bodyPr rtlCol="0" anchor="ctr" wrap="square" lIns="228600" rIns="228600" tIns="182880" bIns="182880"/>
+          <a:bodyPr rtlCol="0" anchor="ctr" wrap="square" lIns="219456" rIns="219456" tIns="182880" bIns="182880"/>
           <a:lstStyle/>
           <a:p>
             <a:pPr algn="ctr">
               <a:spcAft>
                 <a:spcPts val="800"/>
               </a:spcAft>
-              <a:defRPr sz="1400" b="1">
+              <a:defRPr sz="1350" b="1">
                 <a:solidFill>
                   <a:srgbClr val="34D399"/>
                 </a:solidFill>
+                <a:latin typeface="Segoe UI"/>
               </a:defRPr>
             </a:pPr>
             <a:r>
@@ -6115,22 +6229,24 @@
           <a:p>
             <a:pPr>
               <a:spcAft>
-                <a:spcPts val="600"/>
+                <a:spcPts val="550"/>
               </a:spcAft>
             </a:pPr>
             <a:r>
-              <a:rPr b="1" sz="1100">
+              <a:rPr b="1" sz="1050">
                 <a:solidFill>
                   <a:srgbClr val="F8FAFC"/>
                 </a:solidFill>
+                <a:latin typeface="Segoe UI"/>
               </a:rPr>
               <a:t>Baseline Full Array Sort: </a:t>
             </a:r>
             <a:r>
-              <a:rPr sz="1100">
+              <a:rPr sz="1050">
                 <a:solidFill>
                   <a:srgbClr val="94A3B8"/>
                 </a:solidFill>
+                <a:latin typeface="Segoe UI"/>
               </a:rPr>
               <a:t>265.00 ms median (272.73 ms mean) — O(N * S_c + N log N).</a:t>
             </a:r>
@@ -6138,22 +6254,24 @@
           <a:p>
             <a:pPr>
               <a:spcAft>
-                <a:spcPts val="600"/>
+                <a:spcPts val="550"/>
               </a:spcAft>
             </a:pPr>
             <a:r>
-              <a:rPr b="1" sz="1100">
+              <a:rPr b="1" sz="1050">
                 <a:solidFill>
                   <a:srgbClr val="F8FAFC"/>
                 </a:solidFill>
+                <a:latin typeface="Segoe UI"/>
               </a:rPr>
               <a:t>Bucket Sort Full Rank: </a:t>
             </a:r>
             <a:r>
-              <a:rPr sz="1100">
+              <a:rPr sz="1050">
                 <a:solidFill>
                   <a:srgbClr val="94A3B8"/>
                 </a:solidFill>
+                <a:latin typeface="Segoe UI"/>
               </a:rPr>
               <a:t>253.88 ms median (279.97 ms mean) — ~1x speedup (no significant gain because all non-empty buckets must still be sorted in full).</a:t>
             </a:r>
@@ -6161,22 +6279,24 @@
           <a:p>
             <a:pPr>
               <a:spcAft>
-                <a:spcPts val="600"/>
+                <a:spcPts val="550"/>
               </a:spcAft>
             </a:pPr>
             <a:r>
-              <a:rPr b="1" sz="1100">
+              <a:rPr b="1" sz="1050">
                 <a:solidFill>
                   <a:srgbClr val="F8FAFC"/>
                 </a:solidFill>
+                <a:latin typeface="Segoe UI"/>
               </a:rPr>
               <a:t>Bucket Sort Top-100 Early Exit: </a:t>
             </a:r>
             <a:r>
-              <a:rPr sz="1100">
+              <a:rPr sz="1050">
                 <a:solidFill>
                   <a:srgbClr val="94A3B8"/>
                 </a:solidFill>
+                <a:latin typeface="Segoe UI"/>
               </a:rPr>
               <a:t>102.18 ms median (134.23 ms mean) — ~2x speedup (2.03x mean, 2.59x median) because it skips lower score buckets.</a:t>
             </a:r>
@@ -6191,8 +6311,8 @@
         </p:nvSpPr>
         <p:spPr>
           <a:xfrm>
-            <a:off x="731520" y="4800600"/>
-            <a:ext cx="10698480" cy="1371600"/>
+            <a:off x="731520" y="4754880"/>
+            <a:ext cx="10698480" cy="1645920"/>
           </a:xfrm>
           <a:prstGeom prst="roundRect">
             <a:avLst/>
@@ -6221,17 +6341,18 @@
           </a:fontRef>
         </p:style>
         <p:txBody>
-          <a:bodyPr rtlCol="0" anchor="ctr" wrap="square" lIns="228600" rIns="228600" tIns="182880" bIns="182880"/>
+          <a:bodyPr rtlCol="0" anchor="ctr" wrap="square" lIns="219456" rIns="219456" tIns="182880" bIns="182880"/>
           <a:lstStyle/>
           <a:p>
             <a:pPr algn="ctr">
               <a:spcAft>
                 <a:spcPts val="800"/>
               </a:spcAft>
-              <a:defRPr sz="1400" b="1">
+              <a:defRPr sz="1350" b="1">
                 <a:solidFill>
                   <a:srgbClr val="FBBF24"/>
                 </a:solidFill>
+                <a:latin typeface="Segoe UI"/>
               </a:defRPr>
             </a:pPr>
             <a:r>
@@ -6241,22 +6362,24 @@
           <a:p>
             <a:pPr>
               <a:spcAft>
-                <a:spcPts val="600"/>
+                <a:spcPts val="550"/>
               </a:spcAft>
             </a:pPr>
             <a:r>
-              <a:rPr b="1" sz="1100">
+              <a:rPr b="1" sz="1050">
                 <a:solidFill>
                   <a:srgbClr val="F8FAFC"/>
                 </a:solidFill>
+                <a:latin typeface="Segoe UI"/>
               </a:rPr>
               <a:t>The Inverted Index Advantage: </a:t>
             </a:r>
             <a:r>
-              <a:rPr sz="1100">
+              <a:rPr sz="1050">
                 <a:solidFill>
                   <a:srgbClr val="94A3B8"/>
                 </a:solidFill>
+                <a:latin typeface="Segoe UI"/>
               </a:rPr>
               <a:t>For repeated queries over an existing corpus, an Inverted Index (Map&lt;skill, candidateId[]&gt;) is structurally superior: candidates with zero matching skills are never touched, dropping query time to O(sum |Postings(R_j)|).</a:t>
             </a:r>
@@ -6264,22 +6387,24 @@
           <a:p>
             <a:pPr>
               <a:spcAft>
-                <a:spcPts val="600"/>
+                <a:spcPts val="550"/>
               </a:spcAft>
             </a:pPr>
             <a:r>
-              <a:rPr b="1" sz="1100">
+              <a:rPr b="1" sz="1050">
                 <a:solidFill>
                   <a:srgbClr val="F8FAFC"/>
                 </a:solidFill>
+                <a:latin typeface="Segoe UI"/>
               </a:rPr>
               <a:t>Production Recommendation: </a:t>
             </a:r>
             <a:r>
-              <a:rPr sz="1100">
+              <a:rPr sz="1050">
                 <a:solidFill>
                   <a:srgbClr val="94A3B8"/>
                 </a:solidFill>
+                <a:latin typeface="Segoe UI"/>
               </a:rPr>
               <a:t>Use Bucket Sort for one-off dynamic batches; use an Inverted Index in memory for interactive recruiter search.</a:t>
             </a:r>
@@ -6355,8 +6480,8 @@
         </p:nvSpPr>
         <p:spPr>
           <a:xfrm>
-            <a:off x="731520" y="365760"/>
-            <a:ext cx="2560320" cy="292608"/>
+            <a:off x="731520" y="384048"/>
+            <a:ext cx="2926080" cy="292608"/>
           </a:xfrm>
           <a:prstGeom prst="roundRect">
             <a:avLst/>
@@ -6393,6 +6518,7 @@
                 <a:solidFill>
                   <a:srgbClr val="38BDF8"/>
                 </a:solidFill>
+                <a:latin typeface="Segoe UI"/>
               </a:defRPr>
             </a:pPr>
             <a:r>
@@ -6409,8 +6535,8 @@
         </p:nvSpPr>
         <p:spPr>
           <a:xfrm>
-            <a:off x="10058400" y="365760"/>
-            <a:ext cx="1401775" cy="292608"/>
+            <a:off x="9601200" y="384048"/>
+            <a:ext cx="1858975" cy="292608"/>
           </a:xfrm>
           <a:prstGeom prst="rect">
             <a:avLst/>
@@ -6428,6 +6554,7 @@
                 <a:solidFill>
                   <a:srgbClr val="94A3B8"/>
                 </a:solidFill>
+                <a:latin typeface="Segoe UI"/>
               </a:defRPr>
             </a:pPr>
             <a:r>
@@ -6444,8 +6571,8 @@
         </p:nvSpPr>
         <p:spPr>
           <a:xfrm>
-            <a:off x="731520" y="713232"/>
-            <a:ext cx="10698480" cy="502920"/>
+            <a:off x="731520" y="731520"/>
+            <a:ext cx="10728655" cy="457200"/>
           </a:xfrm>
           <a:prstGeom prst="rect">
             <a:avLst/>
@@ -6459,10 +6586,11 @@
           <a:lstStyle/>
           <a:p>
             <a:pPr>
-              <a:defRPr sz="2200" b="1">
+              <a:defRPr sz="2100" b="1">
                 <a:solidFill>
                   <a:srgbClr val="F8FAFC"/>
                 </a:solidFill>
+                <a:latin typeface="Segoe UI"/>
               </a:defRPr>
             </a:pPr>
             <a:r>
@@ -6479,8 +6607,8 @@
         </p:nvSpPr>
         <p:spPr>
           <a:xfrm>
-            <a:off x="731520" y="1243584"/>
-            <a:ext cx="10698480" cy="320040"/>
+            <a:off x="731520" y="1207008"/>
+            <a:ext cx="10728655" cy="320040"/>
           </a:xfrm>
           <a:prstGeom prst="rect">
             <a:avLst/>
@@ -6494,10 +6622,11 @@
           <a:lstStyle/>
           <a:p>
             <a:pPr>
-              <a:defRPr sz="1200">
+              <a:defRPr sz="1150">
                 <a:solidFill>
                   <a:srgbClr val="94A3B8"/>
                 </a:solidFill>
+                <a:latin typeface="Segoe UI"/>
               </a:defRPr>
             </a:pPr>
             <a:r>
@@ -6514,8 +6643,8 @@
         </p:nvSpPr>
         <p:spPr>
           <a:xfrm>
-            <a:off x="731520" y="1691640"/>
-            <a:ext cx="5212080" cy="4480560"/>
+            <a:off x="731520" y="1645920"/>
+            <a:ext cx="5212080" cy="4754880"/>
           </a:xfrm>
           <a:prstGeom prst="roundRect">
             <a:avLst/>
@@ -6544,17 +6673,18 @@
           </a:fontRef>
         </p:style>
         <p:txBody>
-          <a:bodyPr rtlCol="0" anchor="ctr" wrap="square" lIns="228600" rIns="228600" tIns="182880" bIns="182880"/>
+          <a:bodyPr rtlCol="0" anchor="ctr" wrap="square" lIns="219456" rIns="219456" tIns="182880" bIns="182880"/>
           <a:lstStyle/>
           <a:p>
             <a:pPr algn="ctr">
               <a:spcAft>
                 <a:spcPts val="800"/>
               </a:spcAft>
-              <a:defRPr sz="1400" b="1">
+              <a:defRPr sz="1350" b="1">
                 <a:solidFill>
                   <a:srgbClr val="F87171"/>
                 </a:solidFill>
+                <a:latin typeface="Segoe UI"/>
               </a:defRPr>
             </a:pPr>
             <a:r>
@@ -6564,22 +6694,24 @@
           <a:p>
             <a:pPr>
               <a:spcAft>
-                <a:spcPts val="600"/>
+                <a:spcPts val="550"/>
               </a:spcAft>
             </a:pPr>
             <a:r>
-              <a:rPr b="1" sz="1100">
+              <a:rPr b="1" sz="1050">
                 <a:solidFill>
                   <a:srgbClr val="F8FAFC"/>
                 </a:solidFill>
+                <a:latin typeface="Segoe UI"/>
               </a:rPr>
               <a:t>Fatal Boundary Crash: </a:t>
             </a:r>
             <a:r>
-              <a:rPr sz="1100">
+              <a:rPr sz="1050">
                 <a:solidFill>
                   <a:srgbClr val="94A3B8"/>
                 </a:solidFill>
+                <a:latin typeface="Segoe UI"/>
               </a:rPr>
               <a:t>i &lt;= candidates.length off-by-one boundary caused a fatal TypeError crash on the last iteration.</a:t>
             </a:r>
@@ -6587,22 +6719,24 @@
           <a:p>
             <a:pPr>
               <a:spcAft>
-                <a:spcPts val="600"/>
+                <a:spcPts val="550"/>
               </a:spcAft>
             </a:pPr>
             <a:r>
-              <a:rPr b="1" sz="1100">
+              <a:rPr b="1" sz="1050">
                 <a:solidFill>
                   <a:srgbClr val="F8FAFC"/>
                 </a:solidFill>
+                <a:latin typeface="Segoe UI"/>
               </a:rPr>
               <a:t>Global Scope Leak: </a:t>
             </a:r>
             <a:r>
-              <a:rPr sz="1100">
+              <a:rPr sz="1050">
                 <a:solidFill>
                   <a:srgbClr val="94A3B8"/>
                 </a:solidFill>
+                <a:latin typeface="Segoe UI"/>
               </a:rPr>
               <a:t>i = 0 undeclared loop counter leaked into the global namespace.</a:t>
             </a:r>
@@ -6610,22 +6744,24 @@
           <a:p>
             <a:pPr>
               <a:spcAft>
-                <a:spcPts val="600"/>
+                <a:spcPts val="550"/>
               </a:spcAft>
             </a:pPr>
             <a:r>
-              <a:rPr b="1" sz="1100">
+              <a:rPr b="1" sz="1050">
                 <a:solidFill>
                   <a:srgbClr val="F8FAFC"/>
                 </a:solidFill>
+                <a:latin typeface="Segoe UI"/>
               </a:rPr>
               <a:t>Type Error on Score: </a:t>
             </a:r>
             <a:r>
-              <a:rPr sz="1100">
+              <a:rPr sz="1050">
                 <a:solidFill>
                   <a:srgbClr val="94A3B8"/>
                 </a:solidFill>
+                <a:latin typeface="Segoe UI"/>
               </a:rPr>
               <a:t>score = c.skills.filter(...) assigned an array of strings instead of a numeric count.</a:t>
             </a:r>
@@ -6633,22 +6769,24 @@
           <a:p>
             <a:pPr>
               <a:spcAft>
-                <a:spcPts val="600"/>
+                <a:spcPts val="550"/>
               </a:spcAft>
             </a:pPr>
             <a:r>
-              <a:rPr b="1" sz="1100">
+              <a:rPr b="1" sz="1050">
                 <a:solidFill>
                   <a:srgbClr val="F8FAFC"/>
                 </a:solidFill>
+                <a:latin typeface="Segoe UI"/>
               </a:rPr>
               <a:t>Comparator NaN Invalidation: </a:t>
             </a:r>
             <a:r>
-              <a:rPr sz="1100">
+              <a:rPr sz="1050">
                 <a:solidFill>
                   <a:srgbClr val="94A3B8"/>
                 </a:solidFill>
+                <a:latin typeface="Segoe UI"/>
               </a:rPr>
               <a:t>matches.sort((a,b) =&gt; a.score - b.score) performed array subtraction, resulting in NaN and broken non-deterministic sorting.</a:t>
             </a:r>
@@ -6656,22 +6794,24 @@
           <a:p>
             <a:pPr>
               <a:spcAft>
-                <a:spcPts val="600"/>
+                <a:spcPts val="550"/>
               </a:spcAft>
             </a:pPr>
             <a:r>
-              <a:rPr b="1" sz="1100">
+              <a:rPr b="1" sz="1050">
                 <a:solidFill>
                   <a:srgbClr val="F8FAFC"/>
                 </a:solidFill>
+                <a:latin typeface="Segoe UI"/>
               </a:rPr>
               <a:t>Missing Normalization: </a:t>
             </a:r>
             <a:r>
-              <a:rPr sz="1100">
+              <a:rPr sz="1050">
                 <a:solidFill>
                   <a:srgbClr val="94A3B8"/>
                 </a:solidFill>
+                <a:latin typeface="Segoe UI"/>
               </a:rPr>
               <a:t>Ignored skill casing, allowed duplicate candidate skills to inflate score, and had no deterministic tie-breaker.</a:t>
             </a:r>
@@ -6686,8 +6826,8 @@
         </p:nvSpPr>
         <p:spPr>
           <a:xfrm>
-            <a:off x="6217920" y="1691640"/>
-            <a:ext cx="5212080" cy="4480560"/>
+            <a:off x="6217920" y="1645920"/>
+            <a:ext cx="5212080" cy="4754880"/>
           </a:xfrm>
           <a:prstGeom prst="roundRect">
             <a:avLst/>
@@ -6716,17 +6856,18 @@
           </a:fontRef>
         </p:style>
         <p:txBody>
-          <a:bodyPr rtlCol="0" anchor="ctr" wrap="square" lIns="228600" rIns="228600" tIns="182880" bIns="182880"/>
+          <a:bodyPr rtlCol="0" anchor="ctr" wrap="square" lIns="219456" rIns="219456" tIns="182880" bIns="182880"/>
           <a:lstStyle/>
           <a:p>
             <a:pPr algn="ctr">
               <a:spcAft>
                 <a:spcPts val="800"/>
               </a:spcAft>
-              <a:defRPr sz="1400" b="1">
+              <a:defRPr sz="1350" b="1">
                 <a:solidFill>
                   <a:srgbClr val="818CF8"/>
                 </a:solidFill>
+                <a:latin typeface="Segoe UI"/>
               </a:defRPr>
             </a:pPr>
             <a:r>
@@ -6736,22 +6877,24 @@
           <a:p>
             <a:pPr>
               <a:spcAft>
-                <a:spcPts val="600"/>
+                <a:spcPts val="550"/>
               </a:spcAft>
             </a:pPr>
             <a:r>
-              <a:rPr b="1" sz="1100">
+              <a:rPr b="1" sz="1050">
                 <a:solidFill>
                   <a:srgbClr val="F8FAFC"/>
                 </a:solidFill>
+                <a:latin typeface="Segoe UI"/>
               </a:rPr>
               <a:t>matchCandidatesFixed.ts: </a:t>
             </a:r>
             <a:r>
-              <a:rPr sz="1100">
+              <a:rPr sz="1050">
                 <a:solidFill>
                   <a:srgbClr val="94A3B8"/>
                 </a:solidFill>
+                <a:latin typeface="Segoe UI"/>
               </a:rPr>
               <a:t>Implemented strict TypeScript types, case-normalization, distinct set intersection, and deterministic 4-tier descending sort.</a:t>
             </a:r>
@@ -6759,22 +6902,24 @@
           <a:p>
             <a:pPr>
               <a:spcAft>
-                <a:spcPts val="600"/>
+                <a:spcPts val="550"/>
               </a:spcAft>
             </a:pPr>
             <a:r>
-              <a:rPr b="1" sz="1100">
+              <a:rPr b="1" sz="1050">
                 <a:solidFill>
                   <a:srgbClr val="F8FAFC"/>
                 </a:solidFill>
+                <a:latin typeface="Segoe UI"/>
               </a:rPr>
               <a:t>Dual-Algorithm Parity Tests: </a:t>
             </a:r>
             <a:r>
-              <a:rPr sz="1100">
+              <a:rPr sz="1050">
                 <a:solidFill>
                   <a:srgbClr val="94A3B8"/>
                 </a:solidFill>
+                <a:latin typeface="Segoe UI"/>
               </a:rPr>
               <a:t>Wrote automated tests validating invariant parity and deterministic output between baseline and optimized modules.</a:t>
             </a:r>
@@ -6782,22 +6927,24 @@
           <a:p>
             <a:pPr>
               <a:spcAft>
-                <a:spcPts val="600"/>
+                <a:spcPts val="550"/>
               </a:spcAft>
             </a:pPr>
             <a:r>
-              <a:rPr b="1" sz="1100">
+              <a:rPr b="1" sz="1050">
                 <a:solidFill>
                   <a:srgbClr val="F8FAFC"/>
                 </a:solidFill>
+                <a:latin typeface="Segoe UI"/>
               </a:rPr>
               <a:t>Senior Engineering Reflection: </a:t>
             </a:r>
             <a:r>
-              <a:rPr sz="1100">
+              <a:rPr sz="1050">
                 <a:solidFill>
                   <a:srgbClr val="94A3B8"/>
                 </a:solidFill>
+                <a:latin typeface="Segoe UI"/>
               </a:rPr>
               <a:t>"A developer who glanced at the AI output without reading line-by-line would see syntax that looked reasonable, but ship code that immediately crashed in production with an off-by-one exception, failed to compute numeric scores, and produced non-deterministic sorting due to NaN array arithmetic."</a:t>
             </a:r>
@@ -6805,22 +6952,24 @@
           <a:p>
             <a:pPr>
               <a:spcAft>
-                <a:spcPts val="600"/>
+                <a:spcPts val="550"/>
               </a:spcAft>
             </a:pPr>
             <a:r>
-              <a:rPr b="1" sz="1100">
+              <a:rPr b="1" sz="1050">
                 <a:solidFill>
                   <a:srgbClr val="F8FAFC"/>
                 </a:solidFill>
+                <a:latin typeface="Segoe UI"/>
               </a:rPr>
               <a:t>AI-Native Takeaway: </a:t>
             </a:r>
             <a:r>
-              <a:rPr sz="1100">
+              <a:rPr sz="1050">
                 <a:solidFill>
                   <a:srgbClr val="94A3B8"/>
                 </a:solidFill>
+                <a:latin typeface="Segoe UI"/>
               </a:rPr>
               <a:t>AI accelerates boilerplate in minutes, but human verification, strict typing, and automated testing are non-negotiable.</a:t>
             </a:r>
@@ -6896,8 +7045,8 @@
         </p:nvSpPr>
         <p:spPr>
           <a:xfrm>
-            <a:off x="731520" y="365760"/>
-            <a:ext cx="2560320" cy="292608"/>
+            <a:off x="731520" y="384048"/>
+            <a:ext cx="2926080" cy="292608"/>
           </a:xfrm>
           <a:prstGeom prst="roundRect">
             <a:avLst/>
@@ -6934,6 +7083,7 @@
                 <a:solidFill>
                   <a:srgbClr val="38BDF8"/>
                 </a:solidFill>
+                <a:latin typeface="Segoe UI"/>
               </a:defRPr>
             </a:pPr>
             <a:r>
@@ -6950,8 +7100,8 @@
         </p:nvSpPr>
         <p:spPr>
           <a:xfrm>
-            <a:off x="10058400" y="365760"/>
-            <a:ext cx="1401775" cy="292608"/>
+            <a:off x="9601200" y="384048"/>
+            <a:ext cx="1858975" cy="292608"/>
           </a:xfrm>
           <a:prstGeom prst="rect">
             <a:avLst/>
@@ -6969,6 +7119,7 @@
                 <a:solidFill>
                   <a:srgbClr val="94A3B8"/>
                 </a:solidFill>
+                <a:latin typeface="Segoe UI"/>
               </a:defRPr>
             </a:pPr>
             <a:r>
@@ -6985,8 +7136,8 @@
         </p:nvSpPr>
         <p:spPr>
           <a:xfrm>
-            <a:off x="731520" y="713232"/>
-            <a:ext cx="10698480" cy="502920"/>
+            <a:off x="731520" y="731520"/>
+            <a:ext cx="10728655" cy="457200"/>
           </a:xfrm>
           <a:prstGeom prst="rect">
             <a:avLst/>
@@ -7000,10 +7151,11 @@
           <a:lstStyle/>
           <a:p>
             <a:pPr>
-              <a:defRPr sz="2200" b="1">
+              <a:defRPr sz="2100" b="1">
                 <a:solidFill>
                   <a:srgbClr val="F8FAFC"/>
                 </a:solidFill>
+                <a:latin typeface="Segoe UI"/>
               </a:defRPr>
             </a:pPr>
             <a:r>
@@ -7020,8 +7172,8 @@
         </p:nvSpPr>
         <p:spPr>
           <a:xfrm>
-            <a:off x="731520" y="1243584"/>
-            <a:ext cx="10698480" cy="320040"/>
+            <a:off x="731520" y="1207008"/>
+            <a:ext cx="10728655" cy="320040"/>
           </a:xfrm>
           <a:prstGeom prst="rect">
             <a:avLst/>
@@ -7035,10 +7187,11 @@
           <a:lstStyle/>
           <a:p>
             <a:pPr>
-              <a:defRPr sz="1200">
+              <a:defRPr sz="1150">
                 <a:solidFill>
                   <a:srgbClr val="94A3B8"/>
                 </a:solidFill>
+                <a:latin typeface="Segoe UI"/>
               </a:defRPr>
             </a:pPr>
             <a:r>
@@ -7055,8 +7208,8 @@
         </p:nvSpPr>
         <p:spPr>
           <a:xfrm>
-            <a:off x="731520" y="1691640"/>
-            <a:ext cx="4114800" cy="4480560"/>
+            <a:off x="731520" y="1645920"/>
+            <a:ext cx="4754880" cy="4754880"/>
           </a:xfrm>
           <a:prstGeom prst="roundRect">
             <a:avLst/>
@@ -7085,17 +7238,18 @@
           </a:fontRef>
         </p:style>
         <p:txBody>
-          <a:bodyPr rtlCol="0" anchor="ctr" wrap="square" lIns="228600" rIns="228600" tIns="182880" bIns="182880"/>
+          <a:bodyPr rtlCol="0" anchor="ctr" wrap="square" lIns="219456" rIns="219456" tIns="182880" bIns="182880"/>
           <a:lstStyle/>
           <a:p>
             <a:pPr algn="ctr">
               <a:spcAft>
                 <a:spcPts val="800"/>
               </a:spcAft>
-              <a:defRPr sz="1400" b="1">
+              <a:defRPr sz="1350" b="1">
                 <a:solidFill>
                   <a:srgbClr val="38BDF8"/>
                 </a:solidFill>
+                <a:latin typeface="Segoe UI"/>
               </a:defRPr>
             </a:pPr>
             <a:r>
@@ -7105,22 +7259,24 @@
           <a:p>
             <a:pPr>
               <a:spcAft>
-                <a:spcPts val="600"/>
+                <a:spcPts val="550"/>
               </a:spcAft>
             </a:pPr>
             <a:r>
-              <a:rPr b="1" sz="1100">
+              <a:rPr b="1" sz="1050">
                 <a:solidFill>
                   <a:srgbClr val="F8FAFC"/>
                 </a:solidFill>
+                <a:latin typeface="Segoe UI"/>
               </a:rPr>
               <a:t>Real-Time KPI Cards: </a:t>
             </a:r>
             <a:r>
-              <a:rPr sz="1100">
+              <a:rPr sz="1050">
                 <a:solidFill>
                   <a:srgbClr val="94A3B8"/>
                 </a:solidFill>
+                <a:latin typeface="Segoe UI"/>
               </a:rPr>
               <a:t>Live aggregate counters (48 Total, Needs Review, Shortlisted, Archived) with single-click status filtering.</a:t>
             </a:r>
@@ -7128,22 +7284,24 @@
           <a:p>
             <a:pPr>
               <a:spcAft>
-                <a:spcPts val="600"/>
+                <a:spcPts val="550"/>
               </a:spcAft>
             </a:pPr>
             <a:r>
-              <a:rPr b="1" sz="1100">
+              <a:rPr b="1" sz="1050">
                 <a:solidFill>
                   <a:srgbClr val="F8FAFC"/>
                 </a:solidFill>
+                <a:latin typeface="Segoe UI"/>
               </a:rPr>
               <a:t>Multi-Criteria Filter Bar: </a:t>
             </a:r>
             <a:r>
-              <a:rPr sz="1100">
+              <a:rPr sz="1050">
                 <a:solidFill>
                   <a:srgbClr val="94A3B8"/>
                 </a:solidFill>
+                <a:latin typeface="Segoe UI"/>
               </a:rPr>
               <a:t>Debounced search across candidate names, notes, roles, and skills; range sliders for experience.</a:t>
             </a:r>
@@ -7151,22 +7309,24 @@
           <a:p>
             <a:pPr>
               <a:spcAft>
-                <a:spcPts val="600"/>
+                <a:spcPts val="550"/>
               </a:spcAft>
             </a:pPr>
             <a:r>
-              <a:rPr b="1" sz="1100">
+              <a:rPr b="1" sz="1050">
                 <a:solidFill>
                   <a:srgbClr val="F8FAFC"/>
                 </a:solidFill>
+                <a:latin typeface="Segoe UI"/>
               </a:rPr>
               <a:t>One-Click Triage Actions: </a:t>
             </a:r>
             <a:r>
-              <a:rPr sz="1100">
+              <a:rPr sz="1050">
                 <a:solidFill>
                   <a:srgbClr val="94A3B8"/>
                 </a:solidFill>
+                <a:latin typeface="Segoe UI"/>
               </a:rPr>
               <a:t>Instant Shortlist, Reject, or Reset buttons mutating SQLite via PATCH /api/candidates/:id/status.</a:t>
             </a:r>
@@ -7174,22 +7334,24 @@
           <a:p>
             <a:pPr>
               <a:spcAft>
-                <a:spcPts val="600"/>
+                <a:spcPts val="550"/>
               </a:spcAft>
             </a:pPr>
             <a:r>
-              <a:rPr b="1" sz="1100">
+              <a:rPr b="1" sz="1050">
                 <a:solidFill>
                   <a:srgbClr val="F8FAFC"/>
                 </a:solidFill>
+                <a:latin typeface="Segoe UI"/>
               </a:rPr>
               <a:t>Optimistic Feedback: </a:t>
             </a:r>
             <a:r>
-              <a:rPr sz="1100">
+              <a:rPr sz="1050">
                 <a:solidFill>
                   <a:srgbClr val="94A3B8"/>
                 </a:solidFill>
+                <a:latin typeface="Segoe UI"/>
               </a:rPr>
               <a:t>Immediate UI status badge update with animated toast notification and counter synchronization.</a:t>
             </a:r>
@@ -7197,31 +7359,133 @@
           <a:p>
             <a:pPr>
               <a:spcAft>
-                <a:spcPts val="600"/>
+                <a:spcPts val="550"/>
               </a:spcAft>
             </a:pPr>
             <a:r>
-              <a:rPr b="1" sz="1100">
+              <a:rPr b="1" sz="1050">
                 <a:solidFill>
                   <a:srgbClr val="F8FAFC"/>
                 </a:solidFill>
+                <a:latin typeface="Segoe UI"/>
               </a:rPr>
               <a:t>Accessibility Conscious: </a:t>
             </a:r>
             <a:r>
-              <a:rPr sz="1100">
+              <a:rPr sz="1050">
                 <a:solidFill>
                   <a:srgbClr val="94A3B8"/>
                 </a:solidFill>
+                <a:latin typeface="Segoe UI"/>
               </a:rPr>
               <a:t>Full keyboard navigation, semantic table roles, ARIA labels, and high-contrast styling.</a:t>
             </a:r>
+          </a:p>
+        </p:txBody>
+      </p:sp>
+      <p:sp>
+        <p:nvSpPr>
+          <p:cNvPr id="8" name="Rounded Rectangle 7"/>
+          <p:cNvSpPr/>
+          <p:nvPr/>
+        </p:nvSpPr>
+        <p:spPr>
+          <a:xfrm>
+            <a:off x="5852160" y="1645920"/>
+            <a:ext cx="5577840" cy="256032"/>
+          </a:xfrm>
+          <a:prstGeom prst="roundRect">
+            <a:avLst/>
+          </a:prstGeom>
+          <a:solidFill>
+            <a:srgbClr val="1E293B"/>
+          </a:solidFill>
+          <a:ln w="12700">
+            <a:solidFill>
+              <a:srgbClr val="2A3B53"/>
+            </a:solidFill>
+          </a:ln>
+        </p:spPr>
+        <p:style>
+          <a:lnRef idx="1">
+            <a:schemeClr val="accent1"/>
+          </a:lnRef>
+          <a:fillRef idx="3">
+            <a:schemeClr val="accent1"/>
+          </a:fillRef>
+          <a:effectRef idx="2">
+            <a:schemeClr val="accent1"/>
+          </a:effectRef>
+          <a:fontRef idx="minor">
+            <a:schemeClr val="lt1"/>
+          </a:fontRef>
+        </p:style>
+        <p:txBody>
+          <a:bodyPr rtlCol="0" anchor="ctr" lIns="0" rIns="0" tIns="0" bIns="0"/>
+          <a:lstStyle/>
+          <a:p>
+            <a:pPr algn="ctr">
+              <a:defRPr sz="900" b="1">
+                <a:solidFill>
+                  <a:srgbClr val="38BDF8"/>
+                </a:solidFill>
+                <a:latin typeface="Segoe UI"/>
+              </a:defRPr>
+            </a:pPr>
+            <a:r>
+              <a:t>Main Recruiter Dashboard (KPI Cards &amp; Multi-Filter Bar)</a:t>
+            </a:r>
+          </a:p>
+        </p:txBody>
+      </p:sp>
+      <p:sp>
+        <p:nvSpPr>
+          <p:cNvPr id="9" name="Rounded Rectangle 8"/>
+          <p:cNvSpPr/>
+          <p:nvPr/>
+        </p:nvSpPr>
+        <p:spPr>
+          <a:xfrm>
+            <a:off x="5852160" y="1938528"/>
+            <a:ext cx="5577840" cy="2468880"/>
+          </a:xfrm>
+          <a:prstGeom prst="roundRect">
+            <a:avLst/>
+          </a:prstGeom>
+          <a:solidFill>
+            <a:srgbClr val="0F172A"/>
+          </a:solidFill>
+          <a:ln w="12700">
+            <a:solidFill>
+              <a:srgbClr val="2A3B53"/>
+            </a:solidFill>
+          </a:ln>
+        </p:spPr>
+        <p:style>
+          <a:lnRef idx="1">
+            <a:schemeClr val="accent1"/>
+          </a:lnRef>
+          <a:fillRef idx="3">
+            <a:schemeClr val="accent1"/>
+          </a:fillRef>
+          <a:effectRef idx="2">
+            <a:schemeClr val="accent1"/>
+          </a:effectRef>
+          <a:fontRef idx="minor">
+            <a:schemeClr val="lt1"/>
+          </a:fontRef>
+        </p:style>
+        <p:txBody>
+          <a:bodyPr rtlCol="0" anchor="ctr"/>
+          <a:lstStyle/>
+          <a:p>
+            <a:pPr algn="ctr"/>
           </a:p>
         </p:txBody>
       </p:sp>
       <p:pic>
         <p:nvPicPr>
-          <p:cNvPr id="8" name="Picture 7" descr="01-dashboard-overview.png"/>
+          <p:cNvPr id="10" name="Picture 9" descr="01-dashboard-overview.png"/>
           <p:cNvPicPr>
             <a:picLocks noChangeAspect="1"/>
           </p:cNvPicPr>
@@ -7235,17 +7499,117 @@
         </p:blipFill>
         <p:spPr>
           <a:xfrm>
-            <a:off x="5120640" y="1691640"/>
-            <a:ext cx="6309360" cy="2988320"/>
+            <a:off x="5852160" y="1938528"/>
+            <a:ext cx="5577840" cy="2468880"/>
           </a:xfrm>
           <a:prstGeom prst="rect">
             <a:avLst/>
           </a:prstGeom>
         </p:spPr>
       </p:pic>
+      <p:sp>
+        <p:nvSpPr>
+          <p:cNvPr id="11" name="Rounded Rectangle 10"/>
+          <p:cNvSpPr/>
+          <p:nvPr/>
+        </p:nvSpPr>
+        <p:spPr>
+          <a:xfrm>
+            <a:off x="5852160" y="4462272"/>
+            <a:ext cx="5577840" cy="256032"/>
+          </a:xfrm>
+          <a:prstGeom prst="roundRect">
+            <a:avLst/>
+          </a:prstGeom>
+          <a:solidFill>
+            <a:srgbClr val="1E293B"/>
+          </a:solidFill>
+          <a:ln w="12700">
+            <a:solidFill>
+              <a:srgbClr val="2A3B53"/>
+            </a:solidFill>
+          </a:ln>
+        </p:spPr>
+        <p:style>
+          <a:lnRef idx="1">
+            <a:schemeClr val="accent1"/>
+          </a:lnRef>
+          <a:fillRef idx="3">
+            <a:schemeClr val="accent1"/>
+          </a:fillRef>
+          <a:effectRef idx="2">
+            <a:schemeClr val="accent1"/>
+          </a:effectRef>
+          <a:fontRef idx="minor">
+            <a:schemeClr val="lt1"/>
+          </a:fontRef>
+        </p:style>
+        <p:txBody>
+          <a:bodyPr rtlCol="0" anchor="ctr" lIns="0" rIns="0" tIns="0" bIns="0"/>
+          <a:lstStyle/>
+          <a:p>
+            <a:pPr algn="ctr">
+              <a:defRPr sz="900" b="1">
+                <a:solidFill>
+                  <a:srgbClr val="38BDF8"/>
+                </a:solidFill>
+                <a:latin typeface="Segoe UI"/>
+              </a:defRPr>
+            </a:pPr>
+            <a:r>
+              <a:t>Instant Status Mutation with Animated Toast Confirmation</a:t>
+            </a:r>
+          </a:p>
+        </p:txBody>
+      </p:sp>
+      <p:sp>
+        <p:nvSpPr>
+          <p:cNvPr id="12" name="Rounded Rectangle 11"/>
+          <p:cNvSpPr/>
+          <p:nvPr/>
+        </p:nvSpPr>
+        <p:spPr>
+          <a:xfrm>
+            <a:off x="5852160" y="4754880"/>
+            <a:ext cx="5577840" cy="1536192"/>
+          </a:xfrm>
+          <a:prstGeom prst="roundRect">
+            <a:avLst/>
+          </a:prstGeom>
+          <a:solidFill>
+            <a:srgbClr val="0F172A"/>
+          </a:solidFill>
+          <a:ln w="12700">
+            <a:solidFill>
+              <a:srgbClr val="2A3B53"/>
+            </a:solidFill>
+          </a:ln>
+        </p:spPr>
+        <p:style>
+          <a:lnRef idx="1">
+            <a:schemeClr val="accent1"/>
+          </a:lnRef>
+          <a:fillRef idx="3">
+            <a:schemeClr val="accent1"/>
+          </a:fillRef>
+          <a:effectRef idx="2">
+            <a:schemeClr val="accent1"/>
+          </a:effectRef>
+          <a:fontRef idx="minor">
+            <a:schemeClr val="lt1"/>
+          </a:fontRef>
+        </p:style>
+        <p:txBody>
+          <a:bodyPr rtlCol="0" anchor="ctr"/>
+          <a:lstStyle/>
+          <a:p>
+            <a:pPr algn="ctr"/>
+          </a:p>
+        </p:txBody>
+      </p:sp>
       <p:pic>
         <p:nvPicPr>
-          <p:cNvPr id="9" name="Picture 8" descr="04-triage-action-toast.png"/>
+          <p:cNvPr id="13" name="Picture 12" descr="04-triage-action-toast.png"/>
           <p:cNvPicPr>
             <a:picLocks noChangeAspect="1"/>
           </p:cNvPicPr>
@@ -7259,8 +7623,8 @@
         </p:blipFill>
         <p:spPr>
           <a:xfrm>
-            <a:off x="5120640" y="4663440"/>
-            <a:ext cx="6309360" cy="2279749"/>
+            <a:off x="5852160" y="4754880"/>
+            <a:ext cx="5577840" cy="1536192"/>
           </a:xfrm>
           <a:prstGeom prst="rect">
             <a:avLst/>
@@ -7336,8 +7700,8 @@
         </p:nvSpPr>
         <p:spPr>
           <a:xfrm>
-            <a:off x="731520" y="365760"/>
-            <a:ext cx="2560320" cy="292608"/>
+            <a:off x="731520" y="384048"/>
+            <a:ext cx="2926080" cy="292608"/>
           </a:xfrm>
           <a:prstGeom prst="roundRect">
             <a:avLst/>
@@ -7374,6 +7738,7 @@
                 <a:solidFill>
                   <a:srgbClr val="38BDF8"/>
                 </a:solidFill>
+                <a:latin typeface="Segoe UI"/>
               </a:defRPr>
             </a:pPr>
             <a:r>
@@ -7390,8 +7755,8 @@
         </p:nvSpPr>
         <p:spPr>
           <a:xfrm>
-            <a:off x="10058400" y="365760"/>
-            <a:ext cx="1401775" cy="292608"/>
+            <a:off x="9601200" y="384048"/>
+            <a:ext cx="1858975" cy="292608"/>
           </a:xfrm>
           <a:prstGeom prst="rect">
             <a:avLst/>
@@ -7409,6 +7774,7 @@
                 <a:solidFill>
                   <a:srgbClr val="94A3B8"/>
                 </a:solidFill>
+                <a:latin typeface="Segoe UI"/>
               </a:defRPr>
             </a:pPr>
             <a:r>
@@ -7425,8 +7791,8 @@
         </p:nvSpPr>
         <p:spPr>
           <a:xfrm>
-            <a:off x="731520" y="713232"/>
-            <a:ext cx="10698480" cy="502920"/>
+            <a:off x="731520" y="731520"/>
+            <a:ext cx="10728655" cy="457200"/>
           </a:xfrm>
           <a:prstGeom prst="rect">
             <a:avLst/>
@@ -7440,10 +7806,11 @@
           <a:lstStyle/>
           <a:p>
             <a:pPr>
-              <a:defRPr sz="2200" b="1">
+              <a:defRPr sz="2100" b="1">
                 <a:solidFill>
                   <a:srgbClr val="F8FAFC"/>
                 </a:solidFill>
+                <a:latin typeface="Segoe UI"/>
               </a:defRPr>
             </a:pPr>
             <a:r>
@@ -7460,8 +7827,8 @@
         </p:nvSpPr>
         <p:spPr>
           <a:xfrm>
-            <a:off x="731520" y="1243584"/>
-            <a:ext cx="10698480" cy="320040"/>
+            <a:off x="731520" y="1207008"/>
+            <a:ext cx="10728655" cy="320040"/>
           </a:xfrm>
           <a:prstGeom prst="rect">
             <a:avLst/>
@@ -7475,21 +7842,122 @@
           <a:lstStyle/>
           <a:p>
             <a:pPr>
-              <a:defRPr sz="1200">
+              <a:defRPr sz="1150">
                 <a:solidFill>
                   <a:srgbClr val="94A3B8"/>
                 </a:solidFill>
+                <a:latin typeface="Segoe UI"/>
               </a:defRPr>
             </a:pPr>
             <a:r>
               <a:t>Targeted gap analysis and interview probing flags powered by gemini-3.8-flash</a:t>
             </a:r>
+          </a:p>
+        </p:txBody>
+      </p:sp>
+      <p:sp>
+        <p:nvSpPr>
+          <p:cNvPr id="7" name="Rounded Rectangle 6"/>
+          <p:cNvSpPr/>
+          <p:nvPr/>
+        </p:nvSpPr>
+        <p:spPr>
+          <a:xfrm>
+            <a:off x="731520" y="1645920"/>
+            <a:ext cx="3246120" cy="256032"/>
+          </a:xfrm>
+          <a:prstGeom prst="roundRect">
+            <a:avLst/>
+          </a:prstGeom>
+          <a:solidFill>
+            <a:srgbClr val="1E293B"/>
+          </a:solidFill>
+          <a:ln w="12700">
+            <a:solidFill>
+              <a:srgbClr val="2A3B53"/>
+            </a:solidFill>
+          </a:ln>
+        </p:spPr>
+        <p:style>
+          <a:lnRef idx="1">
+            <a:schemeClr val="accent1"/>
+          </a:lnRef>
+          <a:fillRef idx="3">
+            <a:schemeClr val="accent1"/>
+          </a:fillRef>
+          <a:effectRef idx="2">
+            <a:schemeClr val="accent1"/>
+          </a:effectRef>
+          <a:fontRef idx="minor">
+            <a:schemeClr val="lt1"/>
+          </a:fontRef>
+        </p:style>
+        <p:txBody>
+          <a:bodyPr rtlCol="0" anchor="ctr" lIns="0" rIns="0" tIns="0" bIns="0"/>
+          <a:lstStyle/>
+          <a:p>
+            <a:pPr algn="ctr">
+              <a:defRPr sz="900" b="1">
+                <a:solidFill>
+                  <a:srgbClr val="38BDF8"/>
+                </a:solidFill>
+                <a:latin typeface="Segoe UI"/>
+              </a:defRPr>
+            </a:pPr>
+            <a:r>
+              <a:t>Candidate Drawer &amp; Qualitative Notes</a:t>
+            </a:r>
+          </a:p>
+        </p:txBody>
+      </p:sp>
+      <p:sp>
+        <p:nvSpPr>
+          <p:cNvPr id="8" name="Rounded Rectangle 7"/>
+          <p:cNvSpPr/>
+          <p:nvPr/>
+        </p:nvSpPr>
+        <p:spPr>
+          <a:xfrm>
+            <a:off x="731520" y="1938528"/>
+            <a:ext cx="3246120" cy="4343400"/>
+          </a:xfrm>
+          <a:prstGeom prst="roundRect">
+            <a:avLst/>
+          </a:prstGeom>
+          <a:solidFill>
+            <a:srgbClr val="0F172A"/>
+          </a:solidFill>
+          <a:ln w="12700">
+            <a:solidFill>
+              <a:srgbClr val="2A3B53"/>
+            </a:solidFill>
+          </a:ln>
+        </p:spPr>
+        <p:style>
+          <a:lnRef idx="1">
+            <a:schemeClr val="accent1"/>
+          </a:lnRef>
+          <a:fillRef idx="3">
+            <a:schemeClr val="accent1"/>
+          </a:fillRef>
+          <a:effectRef idx="2">
+            <a:schemeClr val="accent1"/>
+          </a:effectRef>
+          <a:fontRef idx="minor">
+            <a:schemeClr val="lt1"/>
+          </a:fontRef>
+        </p:style>
+        <p:txBody>
+          <a:bodyPr rtlCol="0" anchor="ctr"/>
+          <a:lstStyle/>
+          <a:p>
+            <a:pPr algn="ctr"/>
           </a:p>
         </p:txBody>
       </p:sp>
       <p:pic>
         <p:nvPicPr>
-          <p:cNvPr id="7" name="Picture 6" descr="02-candidate-drawer.png"/>
+          <p:cNvPr id="9" name="Picture 8" descr="02-candidate-drawer.png"/>
           <p:cNvPicPr>
             <a:picLocks noChangeAspect="1"/>
           </p:cNvPicPr>
@@ -7503,17 +7971,117 @@
         </p:blipFill>
         <p:spPr>
           <a:xfrm>
-            <a:off x="731520" y="1691640"/>
-            <a:ext cx="3383280" cy="4340361"/>
+            <a:off x="731520" y="1938528"/>
+            <a:ext cx="3246120" cy="4343400"/>
           </a:xfrm>
           <a:prstGeom prst="rect">
             <a:avLst/>
           </a:prstGeom>
         </p:spPr>
       </p:pic>
+      <p:sp>
+        <p:nvSpPr>
+          <p:cNvPr id="10" name="Rounded Rectangle 9"/>
+          <p:cNvSpPr/>
+          <p:nvPr/>
+        </p:nvSpPr>
+        <p:spPr>
+          <a:xfrm>
+            <a:off x="4206240" y="1645920"/>
+            <a:ext cx="3246120" cy="256032"/>
+          </a:xfrm>
+          <a:prstGeom prst="roundRect">
+            <a:avLst/>
+          </a:prstGeom>
+          <a:solidFill>
+            <a:srgbClr val="1E293B"/>
+          </a:solidFill>
+          <a:ln w="12700">
+            <a:solidFill>
+              <a:srgbClr val="2A3B53"/>
+            </a:solidFill>
+          </a:ln>
+        </p:spPr>
+        <p:style>
+          <a:lnRef idx="1">
+            <a:schemeClr val="accent1"/>
+          </a:lnRef>
+          <a:fillRef idx="3">
+            <a:schemeClr val="accent1"/>
+          </a:fillRef>
+          <a:effectRef idx="2">
+            <a:schemeClr val="accent1"/>
+          </a:effectRef>
+          <a:fontRef idx="minor">
+            <a:schemeClr val="lt1"/>
+          </a:fontRef>
+        </p:style>
+        <p:txBody>
+          <a:bodyPr rtlCol="0" anchor="ctr" lIns="0" rIns="0" tIns="0" bIns="0"/>
+          <a:lstStyle/>
+          <a:p>
+            <a:pPr algn="ctr">
+              <a:defRPr sz="900" b="1">
+                <a:solidFill>
+                  <a:srgbClr val="38BDF8"/>
+                </a:solidFill>
+                <a:latin typeface="Segoe UI"/>
+              </a:defRPr>
+            </a:pPr>
+            <a:r>
+              <a:t>Structured Gemini 3.8 Flash Fit Report</a:t>
+            </a:r>
+          </a:p>
+        </p:txBody>
+      </p:sp>
+      <p:sp>
+        <p:nvSpPr>
+          <p:cNvPr id="11" name="Rounded Rectangle 10"/>
+          <p:cNvSpPr/>
+          <p:nvPr/>
+        </p:nvSpPr>
+        <p:spPr>
+          <a:xfrm>
+            <a:off x="4206240" y="1938528"/>
+            <a:ext cx="3246120" cy="4343400"/>
+          </a:xfrm>
+          <a:prstGeom prst="roundRect">
+            <a:avLst/>
+          </a:prstGeom>
+          <a:solidFill>
+            <a:srgbClr val="0F172A"/>
+          </a:solidFill>
+          <a:ln w="12700">
+            <a:solidFill>
+              <a:srgbClr val="2A3B53"/>
+            </a:solidFill>
+          </a:ln>
+        </p:spPr>
+        <p:style>
+          <a:lnRef idx="1">
+            <a:schemeClr val="accent1"/>
+          </a:lnRef>
+          <a:fillRef idx="3">
+            <a:schemeClr val="accent1"/>
+          </a:fillRef>
+          <a:effectRef idx="2">
+            <a:schemeClr val="accent1"/>
+          </a:effectRef>
+          <a:fontRef idx="minor">
+            <a:schemeClr val="lt1"/>
+          </a:fontRef>
+        </p:style>
+        <p:txBody>
+          <a:bodyPr rtlCol="0" anchor="ctr"/>
+          <a:lstStyle/>
+          <a:p>
+            <a:pPr algn="ctr"/>
+          </a:p>
+        </p:txBody>
+      </p:sp>
       <p:pic>
         <p:nvPicPr>
-          <p:cNvPr id="8" name="Picture 7" descr="03-gemini-fit-evaluation.png"/>
+          <p:cNvPr id="12" name="Picture 11" descr="03-gemini-fit-evaluation.png"/>
           <p:cNvPicPr>
             <a:picLocks noChangeAspect="1"/>
           </p:cNvPicPr>
@@ -7527,8 +8095,8 @@
         </p:blipFill>
         <p:spPr>
           <a:xfrm>
-            <a:off x="4297680" y="1691640"/>
-            <a:ext cx="3383280" cy="4395198"/>
+            <a:off x="4206240" y="1938528"/>
+            <a:ext cx="3246120" cy="4343400"/>
           </a:xfrm>
           <a:prstGeom prst="rect">
             <a:avLst/>
@@ -7537,14 +8105,14 @@
       </p:pic>
       <p:sp>
         <p:nvSpPr>
-          <p:cNvPr id="9" name="Rounded Rectangle 8"/>
+          <p:cNvPr id="13" name="Rounded Rectangle 12"/>
           <p:cNvSpPr/>
           <p:nvPr/>
         </p:nvSpPr>
         <p:spPr>
           <a:xfrm>
-            <a:off x="7863840" y="1691640"/>
-            <a:ext cx="3566160" cy="4480560"/>
+            <a:off x="7680960" y="1645920"/>
+            <a:ext cx="3749039" cy="4754880"/>
           </a:xfrm>
           <a:prstGeom prst="roundRect">
             <a:avLst/>
@@ -7573,42 +8141,45 @@
           </a:fontRef>
         </p:style>
         <p:txBody>
-          <a:bodyPr rtlCol="0" anchor="ctr" wrap="square" lIns="228600" rIns="228600" tIns="182880" bIns="182880"/>
+          <a:bodyPr rtlCol="0" anchor="ctr" wrap="square" lIns="219456" rIns="219456" tIns="182880" bIns="182880"/>
           <a:lstStyle/>
           <a:p>
             <a:pPr algn="ctr">
               <a:spcAft>
                 <a:spcPts val="800"/>
               </a:spcAft>
-              <a:defRPr sz="1400" b="1">
+              <a:defRPr sz="1350" b="1">
                 <a:solidFill>
                   <a:srgbClr val="818CF8"/>
                 </a:solidFill>
+                <a:latin typeface="Segoe UI"/>
               </a:defRPr>
             </a:pPr>
             <a:r>
-              <a:t>AI Defensive Architecture</a:t>
+              <a:t>Evidence-Grounded AI Architecture</a:t>
             </a:r>
           </a:p>
           <a:p>
             <a:pPr>
               <a:spcAft>
-                <a:spcPts val="600"/>
+                <a:spcPts val="550"/>
               </a:spcAft>
             </a:pPr>
             <a:r>
-              <a:rPr b="1" sz="1100">
+              <a:rPr b="1" sz="1050">
                 <a:solidFill>
                   <a:srgbClr val="F8FAFC"/>
                 </a:solidFill>
+                <a:latin typeface="Segoe UI"/>
               </a:rPr>
               <a:t>Zero-Hallucination Retrieval: </a:t>
             </a:r>
             <a:r>
-              <a:rPr sz="1100">
+              <a:rPr sz="1050">
                 <a:solidFill>
                   <a:srgbClr val="94A3B8"/>
                 </a:solidFill>
+                <a:latin typeface="Segoe UI"/>
               </a:rPr>
               <a:t>Candidate facts, experience, and notes are fetched strictly from SQLite on the server; client cannot spoof profile data.</a:t>
             </a:r>
@@ -7616,22 +8187,24 @@
           <a:p>
             <a:pPr>
               <a:spcAft>
-                <a:spcPts val="600"/>
+                <a:spcPts val="550"/>
               </a:spcAft>
             </a:pPr>
             <a:r>
-              <a:rPr b="1" sz="1100">
+              <a:rPr b="1" sz="1050">
                 <a:solidFill>
                   <a:srgbClr val="F8FAFC"/>
                 </a:solidFill>
+                <a:latin typeface="Segoe UI"/>
               </a:rPr>
               <a:t>Prompt Injection Defense: </a:t>
             </a:r>
             <a:r>
-              <a:rPr sz="1100">
+              <a:rPr sz="1050">
                 <a:solidFill>
                   <a:srgbClr val="94A3B8"/>
                 </a:solidFill>
+                <a:latin typeface="Segoe UI"/>
               </a:rPr>
               <a:t>XML fencing (&lt;job_description&gt;, &lt;candidate_profile&gt;) mitigates prompt injection attacks.</a:t>
             </a:r>
@@ -7639,68 +8212,74 @@
           <a:p>
             <a:pPr>
               <a:spcAft>
-                <a:spcPts val="600"/>
+                <a:spcPts val="550"/>
               </a:spcAft>
             </a:pPr>
             <a:r>
-              <a:rPr b="1" sz="1100">
+              <a:rPr b="1" sz="1050">
                 <a:solidFill>
                   <a:srgbClr val="F8FAFC"/>
                 </a:solidFill>
+                <a:latin typeface="Segoe UI"/>
               </a:rPr>
               <a:t>Structured Output: </a:t>
             </a:r>
             <a:r>
-              <a:rPr sz="1100">
+              <a:rPr sz="1050">
                 <a:solidFill>
                   <a:srgbClr val="94A3B8"/>
                 </a:solidFill>
-              </a:rPr>
-              <a:t>Enforces strict JSON schema: Fit Level (Strong, Moderate, Weak), Supported Skills, Missing Gaps, Experience Assessment, and Interview Probing Flags.</a:t>
+                <a:latin typeface="Segoe UI"/>
+              </a:rPr>
+              <a:t>Enforces strict JSON schema: Fit Level (Weak), Supported Skills, Missing Requirements, Experience Assessment, and Interview Probing Flags.</a:t>
             </a:r>
           </a:p>
           <a:p>
             <a:pPr>
               <a:spcAft>
-                <a:spcPts val="600"/>
+                <a:spcPts val="550"/>
               </a:spcAft>
             </a:pPr>
             <a:r>
-              <a:rPr b="1" sz="1100">
+              <a:rPr b="1" sz="1050">
                 <a:solidFill>
                   <a:srgbClr val="F8FAFC"/>
                 </a:solidFill>
+                <a:latin typeface="Segoe UI"/>
               </a:rPr>
               <a:t>Recruiter Decision Support: </a:t>
             </a:r>
             <a:r>
-              <a:rPr sz="1100">
+              <a:rPr sz="1050">
                 <a:solidFill>
                   <a:srgbClr val="94A3B8"/>
                 </a:solidFill>
-              </a:rPr>
-              <a:t>AI does NOT make automated rejection decisions; it surfaces concrete evidence gaps (e.g. 'Lacks documented frontend frameworks') for human recruiter probing.</a:t>
+                <a:latin typeface="Segoe UI"/>
+              </a:rPr>
+              <a:t>Surfaces concrete evidence gaps for human probing, rather than automated black-box rejections.</a:t>
             </a:r>
           </a:p>
           <a:p>
             <a:pPr>
               <a:spcAft>
-                <a:spcPts val="600"/>
+                <a:spcPts val="550"/>
               </a:spcAft>
             </a:pPr>
             <a:r>
-              <a:rPr b="1" sz="1100">
+              <a:rPr b="1" sz="1050">
                 <a:solidFill>
                   <a:srgbClr val="F8FAFC"/>
                 </a:solidFill>
+                <a:latin typeface="Segoe UI"/>
               </a:rPr>
               <a:t>Provider Resilience: </a:t>
             </a:r>
             <a:r>
-              <a:rPr sz="1100">
+              <a:rPr sz="1050">
                 <a:solidFill>
                   <a:srgbClr val="94A3B8"/>
                 </a:solidFill>
+                <a:latin typeface="Segoe UI"/>
               </a:rPr>
               <a:t>100% mocked automated tests covering 429 rate limits, 503 auth failures, 422 safety blocks, and 502 malformed outputs.</a:t>
             </a:r>
@@ -7776,8 +8355,8 @@
         </p:nvSpPr>
         <p:spPr>
           <a:xfrm>
-            <a:off x="731520" y="365760"/>
-            <a:ext cx="2560320" cy="292608"/>
+            <a:off x="731520" y="384048"/>
+            <a:ext cx="2926080" cy="292608"/>
           </a:xfrm>
           <a:prstGeom prst="roundRect">
             <a:avLst/>
@@ -7814,6 +8393,7 @@
                 <a:solidFill>
                   <a:srgbClr val="38BDF8"/>
                 </a:solidFill>
+                <a:latin typeface="Segoe UI"/>
               </a:defRPr>
             </a:pPr>
             <a:r>
@@ -7830,8 +8410,8 @@
         </p:nvSpPr>
         <p:spPr>
           <a:xfrm>
-            <a:off x="10058400" y="365760"/>
-            <a:ext cx="1401775" cy="292608"/>
+            <a:off x="9601200" y="384048"/>
+            <a:ext cx="1858975" cy="292608"/>
           </a:xfrm>
           <a:prstGeom prst="rect">
             <a:avLst/>
@@ -7849,6 +8429,7 @@
                 <a:solidFill>
                   <a:srgbClr val="94A3B8"/>
                 </a:solidFill>
+                <a:latin typeface="Segoe UI"/>
               </a:defRPr>
             </a:pPr>
             <a:r>
@@ -7865,8 +8446,8 @@
         </p:nvSpPr>
         <p:spPr>
           <a:xfrm>
-            <a:off x="731520" y="713232"/>
-            <a:ext cx="10698480" cy="502920"/>
+            <a:off x="731520" y="731520"/>
+            <a:ext cx="10728655" cy="457200"/>
           </a:xfrm>
           <a:prstGeom prst="rect">
             <a:avLst/>
@@ -7880,10 +8461,11 @@
           <a:lstStyle/>
           <a:p>
             <a:pPr>
-              <a:defRPr sz="2200" b="1">
+              <a:defRPr sz="2100" b="1">
                 <a:solidFill>
                   <a:srgbClr val="F8FAFC"/>
                 </a:solidFill>
+                <a:latin typeface="Segoe UI"/>
               </a:defRPr>
             </a:pPr>
             <a:r>
@@ -7900,8 +8482,8 @@
         </p:nvSpPr>
         <p:spPr>
           <a:xfrm>
-            <a:off x="731520" y="1243584"/>
-            <a:ext cx="10698480" cy="320040"/>
+            <a:off x="731520" y="1207008"/>
+            <a:ext cx="10728655" cy="320040"/>
           </a:xfrm>
           <a:prstGeom prst="rect">
             <a:avLst/>
@@ -7915,10 +8497,11 @@
           <a:lstStyle/>
           <a:p>
             <a:pPr>
-              <a:defRPr sz="1200">
+              <a:defRPr sz="1150">
                 <a:solidFill>
                   <a:srgbClr val="94A3B8"/>
                 </a:solidFill>
+                <a:latin typeface="Segoe UI"/>
               </a:defRPr>
             </a:pPr>
             <a:r>
@@ -7935,8 +8518,8 @@
         </p:nvSpPr>
         <p:spPr>
           <a:xfrm>
-            <a:off x="731520" y="1691640"/>
-            <a:ext cx="5212080" cy="4480560"/>
+            <a:off x="731520" y="1645920"/>
+            <a:ext cx="5212080" cy="4754880"/>
           </a:xfrm>
           <a:prstGeom prst="roundRect">
             <a:avLst/>
@@ -7965,17 +8548,18 @@
           </a:fontRef>
         </p:style>
         <p:txBody>
-          <a:bodyPr rtlCol="0" anchor="ctr" wrap="square" lIns="228600" rIns="228600" tIns="182880" bIns="182880"/>
+          <a:bodyPr rtlCol="0" anchor="ctr" wrap="square" lIns="219456" rIns="219456" tIns="182880" bIns="182880"/>
           <a:lstStyle/>
           <a:p>
             <a:pPr algn="ctr">
               <a:spcAft>
                 <a:spcPts val="800"/>
               </a:spcAft>
-              <a:defRPr sz="1400" b="1">
+              <a:defRPr sz="1350" b="1">
                 <a:solidFill>
                   <a:srgbClr val="38BDF8"/>
                 </a:solidFill>
+                <a:latin typeface="Segoe UI"/>
               </a:defRPr>
             </a:pPr>
             <a:r>
@@ -7985,22 +8569,24 @@
           <a:p>
             <a:pPr>
               <a:spcAft>
-                <a:spcPts val="600"/>
+                <a:spcPts val="550"/>
               </a:spcAft>
             </a:pPr>
             <a:r>
-              <a:rPr b="1" sz="1100">
+              <a:rPr b="1" sz="1050">
                 <a:solidFill>
                   <a:srgbClr val="F8FAFC"/>
                 </a:solidFill>
+                <a:latin typeface="Segoe UI"/>
               </a:rPr>
               <a:t>The #1 Defensible Risk: </a:t>
             </a:r>
             <a:r>
-              <a:rPr sz="1100">
+              <a:rPr sz="1050">
                 <a:solidFill>
                   <a:srgbClr val="94A3B8"/>
                 </a:solidFill>
+                <a:latin typeface="Segoe UI"/>
               </a:rPr>
               <a:t>Skill tag vocabulary variance ('Postgres' vs 'RDBMS'). A naive top-10% keyword pre-filter creates severe false negatives, silently rejecting non-traditional candidates.</a:t>
             </a:r>
@@ -8008,22 +8594,24 @@
           <a:p>
             <a:pPr>
               <a:spcAft>
-                <a:spcPts val="600"/>
+                <a:spcPts val="550"/>
               </a:spcAft>
             </a:pPr>
             <a:r>
-              <a:rPr b="1" sz="1100">
+              <a:rPr b="1" sz="1050">
                 <a:solidFill>
                   <a:srgbClr val="F8FAFC"/>
                 </a:solidFill>
+                <a:latin typeface="Segoe UI"/>
               </a:rPr>
               <a:t>Per-Requisition Intake: </a:t>
             </a:r>
             <a:r>
-              <a:rPr sz="1100">
+              <a:rPr sz="1050">
                 <a:solidFill>
                   <a:srgbClr val="94A3B8"/>
                 </a:solidFill>
+                <a:latin typeface="Segoe UI"/>
               </a:rPr>
               <a:t>Candidates apply across distinct roles; ingest asynchronously via BullMQ/Redis buffer (~430 candidates/day).</a:t>
             </a:r>
@@ -8031,22 +8619,24 @@
           <a:p>
             <a:pPr>
               <a:spcAft>
-                <a:spcPts val="600"/>
+                <a:spcPts val="550"/>
               </a:spcAft>
             </a:pPr>
             <a:r>
-              <a:rPr b="1" sz="1100">
+              <a:rPr b="1" sz="1050">
                 <a:solidFill>
                   <a:srgbClr val="F8FAFC"/>
                 </a:solidFill>
+                <a:latin typeface="Segoe UI"/>
               </a:rPr>
               <a:t>Recruiter-Selected Triage: </a:t>
             </a:r>
             <a:r>
-              <a:rPr sz="1100">
+              <a:rPr sz="1050">
                 <a:solidFill>
                   <a:srgbClr val="94A3B8"/>
                 </a:solidFill>
+                <a:latin typeface="Segoe UI"/>
               </a:rPr>
               <a:t>Present ranked candidates per open role; allow recruiters to select candidate batches for LLM evaluation rather than an automated top-10% cutoff.</a:t>
             </a:r>
@@ -8054,22 +8644,24 @@
           <a:p>
             <a:pPr>
               <a:spcAft>
-                <a:spcPts val="600"/>
+                <a:spcPts val="550"/>
               </a:spcAft>
             </a:pPr>
             <a:r>
-              <a:rPr b="1" sz="1100">
+              <a:rPr b="1" sz="1050">
                 <a:solidFill>
                   <a:srgbClr val="F8FAFC"/>
                 </a:solidFill>
+                <a:latin typeface="Segoe UI"/>
               </a:rPr>
               <a:t>Hashed Evaluation Caching: </a:t>
             </a:r>
             <a:r>
-              <a:rPr sz="1100">
+              <a:rPr sz="1050">
                 <a:solidFill>
                   <a:srgbClr val="94A3B8"/>
                 </a:solidFill>
+                <a:latin typeface="Segoe UI"/>
               </a:rPr>
               <a:t>Cache fit evaluations by SHA256(candidateId + jdHash) in Redis to eliminate redundant token consumption.</a:t>
             </a:r>
@@ -8077,22 +8669,24 @@
           <a:p>
             <a:pPr>
               <a:spcAft>
-                <a:spcPts val="600"/>
+                <a:spcPts val="550"/>
               </a:spcAft>
             </a:pPr>
             <a:r>
-              <a:rPr b="1" sz="1100">
+              <a:rPr b="1" sz="1050">
                 <a:solidFill>
                   <a:srgbClr val="F8FAFC"/>
                 </a:solidFill>
+                <a:latin typeface="Segoe UI"/>
               </a:rPr>
               <a:t>Audit Logging &amp; Compliance: </a:t>
             </a:r>
             <a:r>
-              <a:rPr sz="1100">
+              <a:rPr sz="1050">
                 <a:solidFill>
                   <a:srgbClr val="94A3B8"/>
                 </a:solidFill>
+                <a:latin typeface="Segoe UI"/>
               </a:rPr>
               <a:t>Maintain append-only triage audit trail ensuring compliance with NYC Local Law 144 / EEOC guidelines.</a:t>
             </a:r>
@@ -8107,8 +8701,8 @@
         </p:nvSpPr>
         <p:spPr>
           <a:xfrm>
-            <a:off x="6217920" y="1691640"/>
-            <a:ext cx="5212080" cy="4480560"/>
+            <a:off x="6217920" y="1645920"/>
+            <a:ext cx="5212080" cy="4754880"/>
           </a:xfrm>
           <a:prstGeom prst="roundRect">
             <a:avLst/>
@@ -8137,17 +8731,18 @@
           </a:fontRef>
         </p:style>
         <p:txBody>
-          <a:bodyPr rtlCol="0" anchor="ctr" wrap="square" lIns="228600" rIns="228600" tIns="182880" bIns="182880"/>
+          <a:bodyPr rtlCol="0" anchor="ctr" wrap="square" lIns="219456" rIns="219456" tIns="182880" bIns="182880"/>
           <a:lstStyle/>
           <a:p>
             <a:pPr algn="ctr">
               <a:spcAft>
                 <a:spcPts val="800"/>
               </a:spcAft>
-              <a:defRPr sz="1400" b="1">
+              <a:defRPr sz="1350" b="1">
                 <a:solidFill>
                   <a:srgbClr val="818CF8"/>
                 </a:solidFill>
+                <a:latin typeface="Segoe UI"/>
               </a:defRPr>
             </a:pPr>
             <a:r>
@@ -8157,22 +8752,24 @@
           <a:p>
             <a:pPr>
               <a:spcAft>
-                <a:spcPts val="600"/>
+                <a:spcPts val="550"/>
               </a:spcAft>
             </a:pPr>
             <a:r>
-              <a:rPr b="1" sz="1100">
+              <a:rPr b="1" sz="1050">
                 <a:solidFill>
                   <a:srgbClr val="F8FAFC"/>
                 </a:solidFill>
+                <a:latin typeface="Segoe UI"/>
               </a:rPr>
               <a:t>Inverted Skill Index: </a:t>
             </a:r>
             <a:r>
-              <a:rPr sz="1100">
+              <a:rPr sz="1050">
                 <a:solidFill>
                   <a:srgbClr val="94A3B8"/>
                 </a:solidFill>
+                <a:latin typeface="Segoe UI"/>
               </a:rPr>
               <a:t>Build an in-memory inverted index for sub-10ms candidate search across high-volume corpora.</a:t>
             </a:r>
@@ -8180,22 +8777,24 @@
           <a:p>
             <a:pPr>
               <a:spcAft>
-                <a:spcPts val="600"/>
+                <a:spcPts val="550"/>
               </a:spcAft>
             </a:pPr>
             <a:r>
-              <a:rPr b="1" sz="1100">
+              <a:rPr b="1" sz="1050">
                 <a:solidFill>
                   <a:srgbClr val="F8FAFC"/>
                 </a:solidFill>
+                <a:latin typeface="Segoe UI"/>
               </a:rPr>
               <a:t>Local Vector Search: </a:t>
             </a:r>
             <a:r>
-              <a:rPr sz="1100">
+              <a:rPr sz="1050">
                 <a:solidFill>
                   <a:srgbClr val="94A3B8"/>
                 </a:solidFill>
+                <a:latin typeface="Segoe UI"/>
               </a:rPr>
               <a:t>Integrate sqlite-vss embeddings over qualitative recruiter notes to surface soft-skill matches.</a:t>
             </a:r>
@@ -8203,22 +8802,24 @@
           <a:p>
             <a:pPr>
               <a:spcAft>
-                <a:spcPts val="600"/>
+                <a:spcPts val="550"/>
               </a:spcAft>
             </a:pPr>
             <a:r>
-              <a:rPr b="1" sz="1100">
+              <a:rPr b="1" sz="1050">
                 <a:solidFill>
                   <a:srgbClr val="F8FAFC"/>
                 </a:solidFill>
+                <a:latin typeface="Segoe UI"/>
               </a:rPr>
               <a:t>Two-Way ATS Sync: </a:t>
             </a:r>
             <a:r>
-              <a:rPr sz="1100">
+              <a:rPr sz="1050">
                 <a:solidFill>
                   <a:srgbClr val="94A3B8"/>
                 </a:solidFill>
+                <a:latin typeface="Segoe UI"/>
               </a:rPr>
               <a:t>Webhook integrations with Greenhouse and Lever for automated candidate imports and two-way status export.</a:t>
             </a:r>
@@ -8226,22 +8827,24 @@
           <a:p>
             <a:pPr>
               <a:spcAft>
-                <a:spcPts val="600"/>
+                <a:spcPts val="550"/>
               </a:spcAft>
             </a:pPr>
             <a:r>
-              <a:rPr b="1" sz="1100">
+              <a:rPr b="1" sz="1050">
                 <a:solidFill>
                   <a:srgbClr val="F8FAFC"/>
                 </a:solidFill>
+                <a:latin typeface="Segoe UI"/>
               </a:rPr>
               <a:t>Persistent Evaluation Store: </a:t>
             </a:r>
             <a:r>
-              <a:rPr sz="1100">
+              <a:rPr sz="1050">
                 <a:solidFill>
                   <a:srgbClr val="94A3B8"/>
                 </a:solidFill>
+                <a:latin typeface="Segoe UI"/>
               </a:rPr>
               <a:t>Create an evaluations table in SQLite to persist LLM fit summaries and track recruiter agreement rates over time.</a:t>
             </a:r>
@@ -8249,22 +8852,24 @@
           <a:p>
             <a:pPr>
               <a:spcAft>
-                <a:spcPts val="600"/>
+                <a:spcPts val="550"/>
               </a:spcAft>
             </a:pPr>
             <a:r>
-              <a:rPr b="1" sz="1100">
+              <a:rPr b="1" sz="1050">
                 <a:solidFill>
                   <a:srgbClr val="F8FAFC"/>
                 </a:solidFill>
+                <a:latin typeface="Segoe UI"/>
               </a:rPr>
               <a:t>Foundation Delivered: </a:t>
             </a:r>
             <a:r>
-              <a:rPr sz="1100">
+              <a:rPr sz="1050">
                 <a:solidFill>
                   <a:srgbClr val="94A3B8"/>
                 </a:solidFill>
+                <a:latin typeface="Segoe UI"/>
               </a:rPr>
               <a:t>75 automated tests (65 backend in ~25s, 10 frontend in ~2.8s), zero failures, production build verified.</a:t>
             </a:r>

</xml_diff>